<commit_message>
change korean text to human readable encoding
</commit_message>
<xml_diff>
--- a/presentation/KSAS_Spring2026_Presentation.pptx
+++ b/presentation/KSAS_Spring2026_Presentation.pptx
@@ -1,30 +1,41 @@
 
 <file path=ppt/presentation.xml><?xml version="1.0" encoding="utf-8"?>
-<p:presentation xmlns:a="http://schemas.openxmlformats.org/drawingml/2006/main" xmlns:r="http://schemas.openxmlformats.org/officeDocument/2006/relationships" xmlns:p="http://schemas.openxmlformats.org/presentationml/2006/main" embedTrueTypeFonts="1" saveSubsetFonts="1">
+<p:presentation xmlns:a="http://schemas.openxmlformats.org/drawingml/2006/main" xmlns:r="http://schemas.openxmlformats.org/officeDocument/2006/relationships" xmlns:p="http://schemas.openxmlformats.org/presentationml/2006/main" saveSubsetFonts="1" embedTrueTypeFonts="true">
   <p:sldMasterIdLst>
     <p:sldMasterId id="2147483648" r:id="rId1"/>
   </p:sldMasterIdLst>
   <p:sldIdLst>
-    <p:sldId id="256" r:id="rId2"/>
-    <p:sldId id="257" r:id="rId3"/>
-    <p:sldId id="258" r:id="rId4"/>
-    <p:sldId id="259" r:id="rId5"/>
-    <p:sldId id="260" r:id="rId6"/>
-    <p:sldId id="261" r:id="rId7"/>
-    <p:sldId id="262" r:id="rId8"/>
-    <p:sldId id="263" r:id="rId9"/>
-    <p:sldId id="264" r:id="rId10"/>
-    <p:sldId id="265" r:id="rId11"/>
-    <p:sldId id="266" r:id="rId12"/>
-    <p:sldId id="267" r:id="rId13"/>
+    <p:sldId id="256" r:id="rId10"/>
+    <p:sldId id="257" r:id="rId11"/>
+    <p:sldId id="258" r:id="rId12"/>
+    <p:sldId id="259" r:id="rId13"/>
+    <p:sldId id="260" r:id="rId14"/>
+    <p:sldId id="261" r:id="rId15"/>
+    <p:sldId id="262" r:id="rId9"/>
+    <p:sldId id="263" r:id="rId8"/>
+    <p:sldId id="264" r:id="rId7"/>
+    <p:sldId id="265" r:id="rId6"/>
+    <p:sldId id="266" r:id="rId20"/>
+    <p:sldId id="267" r:id="rId21"/>
   </p:sldIdLst>
   <p:sldSz cx="18288000" cy="10287000"/>
   <p:notesSz cx="6858000" cy="9144000"/>
   <p:embeddedFontLst>
     <p:embeddedFont>
-      <p:font typeface="각진펜 Bold" panose="020B0500000000000000" pitchFamily="34" charset="-127"/>
-      <p:regular r:id="rId14"/>
-      <p:bold r:id="rId15"/>
+      <p:font typeface="각진펜 Bold" charset="1" panose="020B0500000000000000"/>
+      <p:regular r:id="rId16"/>
+    </p:embeddedFont>
+    <p:embeddedFont>
+      <p:font typeface="Gotham Bold" charset="1" panose="00000000000000000000"/>
+      <p:regular r:id="rId17"/>
+    </p:embeddedFont>
+    <p:embeddedFont>
+      <p:font typeface="Nanum Square" charset="1" panose="020B0600000101010101"/>
+      <p:regular r:id="rId18"/>
+    </p:embeddedFont>
+    <p:embeddedFont>
+      <p:font typeface="Gotham" charset="1" panose="00000000000000000000"/>
+      <p:regular r:id="rId19"/>
     </p:embeddedFont>
   </p:embeddedFontLst>
   <p:defaultTextStyle>
@@ -122,22 +133,6 @@
       </a:defRPr>
     </a:lvl9pPr>
   </p:defaultTextStyle>
-  <p:extLst>
-    <p:ext uri="{EFAFB233-063F-42B5-8137-9DF3F51BA10A}">
-      <p15:sldGuideLst xmlns:p15="http://schemas.microsoft.com/office/powerpoint/2012/main">
-        <p15:guide id="1" orient="horz" pos="2160">
-          <p15:clr>
-            <a:srgbClr val="A4A3A4"/>
-          </p15:clr>
-        </p15:guide>
-        <p15:guide id="2" pos="2880">
-          <p15:clr>
-            <a:srgbClr val="A4A3A4"/>
-          </p15:clr>
-        </p15:guide>
-      </p15:sldGuideLst>
-    </p:ext>
-  </p:extLst>
 </p:presentation>
 </file>
 
@@ -179,9 +174,10 @@
           <a:lstStyle/>
           <a:p>
             <a:r>
-              <a:rPr lang="en-US"/>
+              <a:rPr lang="en-US" smtClean="0"/>
               <a:t>Click to edit Master title style</a:t>
             </a:r>
+            <a:endParaRPr lang="en-US"/>
           </a:p>
         </p:txBody>
       </p:sp>
@@ -297,9 +293,10 @@
           </a:lstStyle>
           <a:p>
             <a:r>
-              <a:rPr lang="en-US"/>
+              <a:rPr lang="en-US" smtClean="0"/>
               <a:t>Click to edit Master subtitle style</a:t>
             </a:r>
+            <a:endParaRPr lang="en-US"/>
           </a:p>
         </p:txBody>
       </p:sp>
@@ -321,7 +318,7 @@
             <a:fld id="{1D8BD707-D9CF-40AE-B4C6-C98DA3205C09}" type="datetimeFigureOut">
               <a:rPr lang="en-US" smtClean="0"/>
               <a:pPr/>
-              <a:t>3/17/26</a:t>
+              <a:t>8/1/2011</a:t>
             </a:fld>
             <a:endParaRPr lang="en-US"/>
           </a:p>
@@ -411,9 +408,10 @@
           <a:lstStyle/>
           <a:p>
             <a:r>
-              <a:rPr lang="en-US"/>
+              <a:rPr lang="en-US" smtClean="0"/>
               <a:t>Click to edit Master title style</a:t>
             </a:r>
+            <a:endParaRPr lang="en-US"/>
           </a:p>
         </p:txBody>
       </p:sp>
@@ -434,37 +432,38 @@
           <a:p>
             <a:pPr lvl="0"/>
             <a:r>
-              <a:rPr lang="en-US"/>
+              <a:rPr lang="en-US" smtClean="0"/>
               <a:t>Click to edit Master text styles</a:t>
             </a:r>
           </a:p>
           <a:p>
             <a:pPr lvl="1"/>
             <a:r>
-              <a:rPr lang="en-US"/>
+              <a:rPr lang="en-US" smtClean="0"/>
               <a:t>Second level</a:t>
             </a:r>
           </a:p>
           <a:p>
             <a:pPr lvl="2"/>
             <a:r>
-              <a:rPr lang="en-US"/>
+              <a:rPr lang="en-US" smtClean="0"/>
               <a:t>Third level</a:t>
             </a:r>
           </a:p>
           <a:p>
             <a:pPr lvl="3"/>
             <a:r>
-              <a:rPr lang="en-US"/>
+              <a:rPr lang="en-US" smtClean="0"/>
               <a:t>Fourth level</a:t>
             </a:r>
           </a:p>
           <a:p>
             <a:pPr lvl="4"/>
             <a:r>
-              <a:rPr lang="en-US"/>
+              <a:rPr lang="en-US" smtClean="0"/>
               <a:t>Fifth level</a:t>
             </a:r>
+            <a:endParaRPr lang="en-US"/>
           </a:p>
         </p:txBody>
       </p:sp>
@@ -486,7 +485,7 @@
             <a:fld id="{1D8BD707-D9CF-40AE-B4C6-C98DA3205C09}" type="datetimeFigureOut">
               <a:rPr lang="en-US" smtClean="0"/>
               <a:pPr/>
-              <a:t>3/17/26</a:t>
+              <a:t>8/1/2011</a:t>
             </a:fld>
             <a:endParaRPr lang="en-US"/>
           </a:p>
@@ -581,9 +580,10 @@
           <a:lstStyle/>
           <a:p>
             <a:r>
-              <a:rPr lang="en-US"/>
+              <a:rPr lang="en-US" smtClean="0"/>
               <a:t>Click to edit Master title style</a:t>
             </a:r>
+            <a:endParaRPr lang="en-US"/>
           </a:p>
         </p:txBody>
       </p:sp>
@@ -609,37 +609,38 @@
           <a:p>
             <a:pPr lvl="0"/>
             <a:r>
-              <a:rPr lang="en-US"/>
+              <a:rPr lang="en-US" smtClean="0"/>
               <a:t>Click to edit Master text styles</a:t>
             </a:r>
           </a:p>
           <a:p>
             <a:pPr lvl="1"/>
             <a:r>
-              <a:rPr lang="en-US"/>
+              <a:rPr lang="en-US" smtClean="0"/>
               <a:t>Second level</a:t>
             </a:r>
           </a:p>
           <a:p>
             <a:pPr lvl="2"/>
             <a:r>
-              <a:rPr lang="en-US"/>
+              <a:rPr lang="en-US" smtClean="0"/>
               <a:t>Third level</a:t>
             </a:r>
           </a:p>
           <a:p>
             <a:pPr lvl="3"/>
             <a:r>
-              <a:rPr lang="en-US"/>
+              <a:rPr lang="en-US" smtClean="0"/>
               <a:t>Fourth level</a:t>
             </a:r>
           </a:p>
           <a:p>
             <a:pPr lvl="4"/>
             <a:r>
-              <a:rPr lang="en-US"/>
+              <a:rPr lang="en-US" smtClean="0"/>
               <a:t>Fifth level</a:t>
             </a:r>
+            <a:endParaRPr lang="en-US"/>
           </a:p>
         </p:txBody>
       </p:sp>
@@ -661,7 +662,7 @@
             <a:fld id="{1D8BD707-D9CF-40AE-B4C6-C98DA3205C09}" type="datetimeFigureOut">
               <a:rPr lang="en-US" smtClean="0"/>
               <a:pPr/>
-              <a:t>3/17/26</a:t>
+              <a:t>8/1/2011</a:t>
             </a:fld>
             <a:endParaRPr lang="en-US"/>
           </a:p>
@@ -751,9 +752,10 @@
           <a:lstStyle/>
           <a:p>
             <a:r>
-              <a:rPr lang="en-US"/>
+              <a:rPr lang="en-US" smtClean="0"/>
               <a:t>Click to edit Master title style</a:t>
             </a:r>
+            <a:endParaRPr lang="en-US"/>
           </a:p>
         </p:txBody>
       </p:sp>
@@ -774,37 +776,38 @@
           <a:p>
             <a:pPr lvl="0"/>
             <a:r>
-              <a:rPr lang="en-US"/>
+              <a:rPr lang="en-US" smtClean="0"/>
               <a:t>Click to edit Master text styles</a:t>
             </a:r>
           </a:p>
           <a:p>
             <a:pPr lvl="1"/>
             <a:r>
-              <a:rPr lang="en-US"/>
+              <a:rPr lang="en-US" smtClean="0"/>
               <a:t>Second level</a:t>
             </a:r>
           </a:p>
           <a:p>
             <a:pPr lvl="2"/>
             <a:r>
-              <a:rPr lang="en-US"/>
+              <a:rPr lang="en-US" smtClean="0"/>
               <a:t>Third level</a:t>
             </a:r>
           </a:p>
           <a:p>
             <a:pPr lvl="3"/>
             <a:r>
-              <a:rPr lang="en-US"/>
+              <a:rPr lang="en-US" smtClean="0"/>
               <a:t>Fourth level</a:t>
             </a:r>
           </a:p>
           <a:p>
             <a:pPr lvl="4"/>
             <a:r>
-              <a:rPr lang="en-US"/>
+              <a:rPr lang="en-US" smtClean="0"/>
               <a:t>Fifth level</a:t>
             </a:r>
+            <a:endParaRPr lang="en-US"/>
           </a:p>
         </p:txBody>
       </p:sp>
@@ -826,7 +829,7 @@
             <a:fld id="{1D8BD707-D9CF-40AE-B4C6-C98DA3205C09}" type="datetimeFigureOut">
               <a:rPr lang="en-US" smtClean="0"/>
               <a:pPr/>
-              <a:t>3/17/26</a:t>
+              <a:t>8/1/2011</a:t>
             </a:fld>
             <a:endParaRPr lang="en-US"/>
           </a:p>
@@ -925,9 +928,10 @@
           </a:lstStyle>
           <a:p>
             <a:r>
-              <a:rPr lang="en-US"/>
+              <a:rPr lang="en-US" smtClean="0"/>
               <a:t>Click to edit Master title style</a:t>
             </a:r>
+            <a:endParaRPr lang="en-US"/>
           </a:p>
         </p:txBody>
       </p:sp>
@@ -1044,7 +1048,7 @@
           <a:p>
             <a:pPr lvl="0"/>
             <a:r>
-              <a:rPr lang="en-US"/>
+              <a:rPr lang="en-US" smtClean="0"/>
               <a:t>Click to edit Master text styles</a:t>
             </a:r>
           </a:p>
@@ -1068,7 +1072,7 @@
             <a:fld id="{1D8BD707-D9CF-40AE-B4C6-C98DA3205C09}" type="datetimeFigureOut">
               <a:rPr lang="en-US" smtClean="0"/>
               <a:pPr/>
-              <a:t>3/17/26</a:t>
+              <a:t>8/1/2011</a:t>
             </a:fld>
             <a:endParaRPr lang="en-US"/>
           </a:p>
@@ -1158,9 +1162,10 @@
           <a:lstStyle/>
           <a:p>
             <a:r>
-              <a:rPr lang="en-US"/>
+              <a:rPr lang="en-US" smtClean="0"/>
               <a:t>Click to edit Master title style</a:t>
             </a:r>
+            <a:endParaRPr lang="en-US"/>
           </a:p>
         </p:txBody>
       </p:sp>
@@ -1214,37 +1219,38 @@
           <a:p>
             <a:pPr lvl="0"/>
             <a:r>
-              <a:rPr lang="en-US"/>
+              <a:rPr lang="en-US" smtClean="0"/>
               <a:t>Click to edit Master text styles</a:t>
             </a:r>
           </a:p>
           <a:p>
             <a:pPr lvl="1"/>
             <a:r>
-              <a:rPr lang="en-US"/>
+              <a:rPr lang="en-US" smtClean="0"/>
               <a:t>Second level</a:t>
             </a:r>
           </a:p>
           <a:p>
             <a:pPr lvl="2"/>
             <a:r>
-              <a:rPr lang="en-US"/>
+              <a:rPr lang="en-US" smtClean="0"/>
               <a:t>Third level</a:t>
             </a:r>
           </a:p>
           <a:p>
             <a:pPr lvl="3"/>
             <a:r>
-              <a:rPr lang="en-US"/>
+              <a:rPr lang="en-US" smtClean="0"/>
               <a:t>Fourth level</a:t>
             </a:r>
           </a:p>
           <a:p>
             <a:pPr lvl="4"/>
             <a:r>
-              <a:rPr lang="en-US"/>
+              <a:rPr lang="en-US" smtClean="0"/>
               <a:t>Fifth level</a:t>
             </a:r>
+            <a:endParaRPr lang="en-US"/>
           </a:p>
         </p:txBody>
       </p:sp>
@@ -1298,37 +1304,38 @@
           <a:p>
             <a:pPr lvl="0"/>
             <a:r>
-              <a:rPr lang="en-US"/>
+              <a:rPr lang="en-US" smtClean="0"/>
               <a:t>Click to edit Master text styles</a:t>
             </a:r>
           </a:p>
           <a:p>
             <a:pPr lvl="1"/>
             <a:r>
-              <a:rPr lang="en-US"/>
+              <a:rPr lang="en-US" smtClean="0"/>
               <a:t>Second level</a:t>
             </a:r>
           </a:p>
           <a:p>
             <a:pPr lvl="2"/>
             <a:r>
-              <a:rPr lang="en-US"/>
+              <a:rPr lang="en-US" smtClean="0"/>
               <a:t>Third level</a:t>
             </a:r>
           </a:p>
           <a:p>
             <a:pPr lvl="3"/>
             <a:r>
-              <a:rPr lang="en-US"/>
+              <a:rPr lang="en-US" smtClean="0"/>
               <a:t>Fourth level</a:t>
             </a:r>
           </a:p>
           <a:p>
             <a:pPr lvl="4"/>
             <a:r>
-              <a:rPr lang="en-US"/>
+              <a:rPr lang="en-US" smtClean="0"/>
               <a:t>Fifth level</a:t>
             </a:r>
+            <a:endParaRPr lang="en-US"/>
           </a:p>
         </p:txBody>
       </p:sp>
@@ -1350,7 +1357,7 @@
             <a:fld id="{1D8BD707-D9CF-40AE-B4C6-C98DA3205C09}" type="datetimeFigureOut">
               <a:rPr lang="en-US" smtClean="0"/>
               <a:pPr/>
-              <a:t>3/17/26</a:t>
+              <a:t>8/1/2011</a:t>
             </a:fld>
             <a:endParaRPr lang="en-US"/>
           </a:p>
@@ -1444,9 +1451,10 @@
           </a:lstStyle>
           <a:p>
             <a:r>
-              <a:rPr lang="en-US"/>
+              <a:rPr lang="en-US" smtClean="0"/>
               <a:t>Click to edit Master title style</a:t>
             </a:r>
+            <a:endParaRPr lang="en-US"/>
           </a:p>
         </p:txBody>
       </p:sp>
@@ -1509,7 +1517,7 @@
           <a:p>
             <a:pPr lvl="0"/>
             <a:r>
-              <a:rPr lang="en-US"/>
+              <a:rPr lang="en-US" smtClean="0"/>
               <a:t>Click to edit Master text styles</a:t>
             </a:r>
           </a:p>
@@ -1565,37 +1573,38 @@
           <a:p>
             <a:pPr lvl="0"/>
             <a:r>
-              <a:rPr lang="en-US"/>
+              <a:rPr lang="en-US" smtClean="0"/>
               <a:t>Click to edit Master text styles</a:t>
             </a:r>
           </a:p>
           <a:p>
             <a:pPr lvl="1"/>
             <a:r>
-              <a:rPr lang="en-US"/>
+              <a:rPr lang="en-US" smtClean="0"/>
               <a:t>Second level</a:t>
             </a:r>
           </a:p>
           <a:p>
             <a:pPr lvl="2"/>
             <a:r>
-              <a:rPr lang="en-US"/>
+              <a:rPr lang="en-US" smtClean="0"/>
               <a:t>Third level</a:t>
             </a:r>
           </a:p>
           <a:p>
             <a:pPr lvl="3"/>
             <a:r>
-              <a:rPr lang="en-US"/>
+              <a:rPr lang="en-US" smtClean="0"/>
               <a:t>Fourth level</a:t>
             </a:r>
           </a:p>
           <a:p>
             <a:pPr lvl="4"/>
             <a:r>
-              <a:rPr lang="en-US"/>
+              <a:rPr lang="en-US" smtClean="0"/>
               <a:t>Fifth level</a:t>
             </a:r>
+            <a:endParaRPr lang="en-US"/>
           </a:p>
         </p:txBody>
       </p:sp>
@@ -1658,7 +1667,7 @@
           <a:p>
             <a:pPr lvl="0"/>
             <a:r>
-              <a:rPr lang="en-US"/>
+              <a:rPr lang="en-US" smtClean="0"/>
               <a:t>Click to edit Master text styles</a:t>
             </a:r>
           </a:p>
@@ -1714,37 +1723,38 @@
           <a:p>
             <a:pPr lvl="0"/>
             <a:r>
-              <a:rPr lang="en-US"/>
+              <a:rPr lang="en-US" smtClean="0"/>
               <a:t>Click to edit Master text styles</a:t>
             </a:r>
           </a:p>
           <a:p>
             <a:pPr lvl="1"/>
             <a:r>
-              <a:rPr lang="en-US"/>
+              <a:rPr lang="en-US" smtClean="0"/>
               <a:t>Second level</a:t>
             </a:r>
           </a:p>
           <a:p>
             <a:pPr lvl="2"/>
             <a:r>
-              <a:rPr lang="en-US"/>
+              <a:rPr lang="en-US" smtClean="0"/>
               <a:t>Third level</a:t>
             </a:r>
           </a:p>
           <a:p>
             <a:pPr lvl="3"/>
             <a:r>
-              <a:rPr lang="en-US"/>
+              <a:rPr lang="en-US" smtClean="0"/>
               <a:t>Fourth level</a:t>
             </a:r>
           </a:p>
           <a:p>
             <a:pPr lvl="4"/>
             <a:r>
-              <a:rPr lang="en-US"/>
+              <a:rPr lang="en-US" smtClean="0"/>
               <a:t>Fifth level</a:t>
             </a:r>
+            <a:endParaRPr lang="en-US"/>
           </a:p>
         </p:txBody>
       </p:sp>
@@ -1766,7 +1776,7 @@
             <a:fld id="{1D8BD707-D9CF-40AE-B4C6-C98DA3205C09}" type="datetimeFigureOut">
               <a:rPr lang="en-US" smtClean="0"/>
               <a:pPr/>
-              <a:t>3/17/26</a:t>
+              <a:t>8/1/2011</a:t>
             </a:fld>
             <a:endParaRPr lang="en-US"/>
           </a:p>
@@ -1856,9 +1866,10 @@
           <a:lstStyle/>
           <a:p>
             <a:r>
-              <a:rPr lang="en-US"/>
+              <a:rPr lang="en-US" smtClean="0"/>
               <a:t>Click to edit Master title style</a:t>
             </a:r>
+            <a:endParaRPr lang="en-US"/>
           </a:p>
         </p:txBody>
       </p:sp>
@@ -1880,7 +1891,7 @@
             <a:fld id="{1D8BD707-D9CF-40AE-B4C6-C98DA3205C09}" type="datetimeFigureOut">
               <a:rPr lang="en-US" smtClean="0"/>
               <a:pPr/>
-              <a:t>3/17/26</a:t>
+              <a:t>8/1/2011</a:t>
             </a:fld>
             <a:endParaRPr lang="en-US"/>
           </a:p>
@@ -1972,7 +1983,7 @@
             <a:fld id="{1D8BD707-D9CF-40AE-B4C6-C98DA3205C09}" type="datetimeFigureOut">
               <a:rPr lang="en-US" smtClean="0"/>
               <a:pPr/>
-              <a:t>3/17/26</a:t>
+              <a:t>8/1/2011</a:t>
             </a:fld>
             <a:endParaRPr lang="en-US"/>
           </a:p>
@@ -2071,9 +2082,10 @@
           </a:lstStyle>
           <a:p>
             <a:r>
-              <a:rPr lang="en-US"/>
+              <a:rPr lang="en-US" smtClean="0"/>
               <a:t>Click to edit Master title style</a:t>
             </a:r>
+            <a:endParaRPr lang="en-US"/>
           </a:p>
         </p:txBody>
       </p:sp>
@@ -2127,37 +2139,38 @@
           <a:p>
             <a:pPr lvl="0"/>
             <a:r>
-              <a:rPr lang="en-US"/>
+              <a:rPr lang="en-US" smtClean="0"/>
               <a:t>Click to edit Master text styles</a:t>
             </a:r>
           </a:p>
           <a:p>
             <a:pPr lvl="1"/>
             <a:r>
-              <a:rPr lang="en-US"/>
+              <a:rPr lang="en-US" smtClean="0"/>
               <a:t>Second level</a:t>
             </a:r>
           </a:p>
           <a:p>
             <a:pPr lvl="2"/>
             <a:r>
-              <a:rPr lang="en-US"/>
+              <a:rPr lang="en-US" smtClean="0"/>
               <a:t>Third level</a:t>
             </a:r>
           </a:p>
           <a:p>
             <a:pPr lvl="3"/>
             <a:r>
-              <a:rPr lang="en-US"/>
+              <a:rPr lang="en-US" smtClean="0"/>
               <a:t>Fourth level</a:t>
             </a:r>
           </a:p>
           <a:p>
             <a:pPr lvl="4"/>
             <a:r>
-              <a:rPr lang="en-US"/>
+              <a:rPr lang="en-US" smtClean="0"/>
               <a:t>Fifth level</a:t>
             </a:r>
+            <a:endParaRPr lang="en-US"/>
           </a:p>
         </p:txBody>
       </p:sp>
@@ -2220,7 +2233,7 @@
           <a:p>
             <a:pPr lvl="0"/>
             <a:r>
-              <a:rPr lang="en-US"/>
+              <a:rPr lang="en-US" smtClean="0"/>
               <a:t>Click to edit Master text styles</a:t>
             </a:r>
           </a:p>
@@ -2244,7 +2257,7 @@
             <a:fld id="{1D8BD707-D9CF-40AE-B4C6-C98DA3205C09}" type="datetimeFigureOut">
               <a:rPr lang="en-US" smtClean="0"/>
               <a:pPr/>
-              <a:t>3/17/26</a:t>
+              <a:t>8/1/2011</a:t>
             </a:fld>
             <a:endParaRPr lang="en-US"/>
           </a:p>
@@ -2343,9 +2356,10 @@
           </a:lstStyle>
           <a:p>
             <a:r>
-              <a:rPr lang="en-US"/>
+              <a:rPr lang="en-US" smtClean="0"/>
               <a:t>Click to edit Master title style</a:t>
             </a:r>
+            <a:endParaRPr lang="en-US"/>
           </a:p>
         </p:txBody>
       </p:sp>
@@ -2469,7 +2483,7 @@
           <a:p>
             <a:pPr lvl="0"/>
             <a:r>
-              <a:rPr lang="en-US"/>
+              <a:rPr lang="en-US" smtClean="0"/>
               <a:t>Click to edit Master text styles</a:t>
             </a:r>
           </a:p>
@@ -2493,7 +2507,7 @@
             <a:fld id="{1D8BD707-D9CF-40AE-B4C6-C98DA3205C09}" type="datetimeFigureOut">
               <a:rPr lang="en-US" smtClean="0"/>
               <a:pPr/>
-              <a:t>3/17/26</a:t>
+              <a:t>8/1/2011</a:t>
             </a:fld>
             <a:endParaRPr lang="en-US"/>
           </a:p>
@@ -2598,9 +2612,10 @@
           <a:lstStyle/>
           <a:p>
             <a:r>
-              <a:rPr lang="en-US"/>
+              <a:rPr lang="en-US" smtClean="0"/>
               <a:t>Click to edit Master title style</a:t>
             </a:r>
+            <a:endParaRPr lang="en-US"/>
           </a:p>
         </p:txBody>
       </p:sp>
@@ -2631,37 +2646,38 @@
           <a:p>
             <a:pPr lvl="0"/>
             <a:r>
-              <a:rPr lang="en-US"/>
+              <a:rPr lang="en-US" smtClean="0"/>
               <a:t>Click to edit Master text styles</a:t>
             </a:r>
           </a:p>
           <a:p>
             <a:pPr lvl="1"/>
             <a:r>
-              <a:rPr lang="en-US"/>
+              <a:rPr lang="en-US" smtClean="0"/>
               <a:t>Second level</a:t>
             </a:r>
           </a:p>
           <a:p>
             <a:pPr lvl="2"/>
             <a:r>
-              <a:rPr lang="en-US"/>
+              <a:rPr lang="en-US" smtClean="0"/>
               <a:t>Third level</a:t>
             </a:r>
           </a:p>
           <a:p>
             <a:pPr lvl="3"/>
             <a:r>
-              <a:rPr lang="en-US"/>
+              <a:rPr lang="en-US" smtClean="0"/>
               <a:t>Fourth level</a:t>
             </a:r>
           </a:p>
           <a:p>
             <a:pPr lvl="4"/>
             <a:r>
-              <a:rPr lang="en-US"/>
+              <a:rPr lang="en-US" smtClean="0"/>
               <a:t>Fifth level</a:t>
             </a:r>
+            <a:endParaRPr lang="en-US"/>
           </a:p>
         </p:txBody>
       </p:sp>
@@ -2701,7 +2717,7 @@
             <a:fld id="{1D8BD707-D9CF-40AE-B4C6-C98DA3205C09}" type="datetimeFigureOut">
               <a:rPr lang="en-US" smtClean="0"/>
               <a:pPr/>
-              <a:t>3/17/26</a:t>
+              <a:t>8/1/2011</a:t>
             </a:fld>
             <a:endParaRPr lang="en-US"/>
           </a:p>
@@ -3056,7 +3072,7 @@
 </file>
 
 <file path=ppt/slides/slide1.xml><?xml version="1.0" encoding="utf-8"?>
-<p:sld xmlns:a="http://schemas.openxmlformats.org/drawingml/2006/main" xmlns:r="http://schemas.openxmlformats.org/officeDocument/2006/relationships" xmlns:p="http://schemas.openxmlformats.org/presentationml/2006/main">
+<p:sld xmlns:a="http://schemas.openxmlformats.org/drawingml/2006/main" xmlns:p="http://schemas.openxmlformats.org/presentationml/2006/main" xmlns:r="http://schemas.openxmlformats.org/officeDocument/2006/relationships">
   <p:cSld>
     <p:bg>
       <p:bgPr>
@@ -3072,20 +3088,11 @@
         <p:cNvGrpSpPr/>
         <p:nvPr/>
       </p:nvGrpSpPr>
-      <p:grpSpPr>
-        <a:xfrm>
-          <a:off x="0" y="0"/>
-          <a:ext cx="0" cy="0"/>
-          <a:chOff x="0" y="0"/>
-          <a:chExt cx="0" cy="0"/>
-        </a:xfrm>
-      </p:grpSpPr>
+      <p:grpSpPr/>
       <p:sp>
         <p:nvSpPr>
           <p:cNvPr id="2" name="Rectangle 1"/>
-          <p:cNvSpPr>
-            <a:spLocks noGrp="1" noRot="1" noMove="1" noResize="1" noEditPoints="1" noAdjustHandles="1" noChangeArrowheads="1" noChangeShapeType="1"/>
-          </p:cNvSpPr>
+          <p:cNvSpPr/>
           <p:nvPr/>
         </p:nvSpPr>
         <p:spPr>
@@ -3123,20 +3130,19 @@
           <a:lstStyle/>
           <a:p>
             <a:pPr algn="ctr"/>
-            <a:endParaRPr/>
-          </a:p>
-        </p:txBody>
-      </p:sp>
-      <p:sp>
-        <p:nvSpPr>
-          <p:cNvPr id="6" name="TextBox 5"/>
+          </a:p>
+        </p:txBody>
+      </p:sp>
+      <p:sp>
+        <p:nvSpPr>
+          <p:cNvPr id="3" name="TextBox 2"/>
           <p:cNvSpPr txBox="1"/>
           <p:nvPr/>
         </p:nvSpPr>
         <p:spPr>
           <a:xfrm>
-            <a:off x="16642080" y="9646920"/>
-            <a:ext cx="1097280" cy="457200"/>
+            <a:off x="1828800" y="1097280"/>
+            <a:ext cx="14630400" cy="914400"/>
           </a:xfrm>
           <a:prstGeom prst="rect">
             <a:avLst/>
@@ -3149,6 +3155,163 @@
           </a:bodyPr>
           <a:lstStyle/>
           <a:p>
+            <a:pPr algn="ctr">
+              <a:defRPr sz="2400" b="1">
+                <a:solidFill>
+                  <a:srgbClr val="004AAD"/>
+                </a:solidFill>
+              </a:defRPr>
+            </a:pPr>
+            <a:r>
+              <a:t>PHYSICALLY CLOSED-LOOP HILS</a:t>
+            </a:r>
+          </a:p>
+        </p:txBody>
+      </p:sp>
+      <p:sp>
+        <p:nvSpPr>
+          <p:cNvPr id="4" name="TextBox 3"/>
+          <p:cNvSpPr txBox="1"/>
+          <p:nvPr/>
+        </p:nvSpPr>
+        <p:spPr>
+          <a:xfrm>
+            <a:off x="1828800" y="1828800"/>
+            <a:ext cx="14630400" cy="3200400"/>
+          </a:xfrm>
+          <a:prstGeom prst="rect">
+            <a:avLst/>
+          </a:prstGeom>
+          <a:noFill/>
+        </p:spPr>
+        <p:txBody>
+          <a:bodyPr wrap="square">
+            <a:spAutoFit/>
+          </a:bodyPr>
+          <a:lstStyle/>
+          <a:p>
+            <a:pPr algn="ctr">
+              <a:lnSpc>
+                <a:spcPts val="6800"/>
+              </a:lnSpc>
+              <a:defRPr sz="5600" b="1">
+                <a:solidFill>
+                  <a:srgbClr val="000000"/>
+                </a:solidFill>
+              </a:defRPr>
+            </a:pPr>
+            <a:r>
+              <a:t>Physically Closed-Loop HILS for</a:t>
+            </a:r>
+            <a:br/>
+            <a:r>
+              <a:t>Flight Attitude-Control Validation</a:t>
+            </a:r>
+          </a:p>
+          <a:p>
+            <a:pPr algn="ctr">
+              <a:spcBef>
+                <a:spcPts val="2400"/>
+              </a:spcBef>
+              <a:defRPr sz="2200" b="0">
+                <a:solidFill>
+                  <a:srgbClr val="666666"/>
+                </a:solidFill>
+              </a:defRPr>
+            </a:pPr>
+            <a:r>
+              <a:t>Using a Stewart Platform with X-Plane and PX4</a:t>
+            </a:r>
+          </a:p>
+          <a:p>
+            <a:pPr algn="ctr">
+              <a:spcBef>
+                <a:spcPts val="600"/>
+              </a:spcBef>
+              <a:defRPr sz="1800" b="0">
+                <a:solidFill>
+                  <a:srgbClr val="999999"/>
+                </a:solidFill>
+              </a:defRPr>
+            </a:pPr>
+            <a:r>
+              <a:t>스튜어트 플랫폼 · X-Plane · PX4 연동 기반 비행체 자세제어 검증</a:t>
+            </a:r>
+          </a:p>
+        </p:txBody>
+      </p:sp>
+      <p:sp>
+        <p:nvSpPr>
+          <p:cNvPr id="5" name="TextBox 4"/>
+          <p:cNvSpPr txBox="1"/>
+          <p:nvPr/>
+        </p:nvSpPr>
+        <p:spPr>
+          <a:xfrm>
+            <a:off x="1828800" y="6400800"/>
+            <a:ext cx="14630400" cy="914400"/>
+          </a:xfrm>
+          <a:prstGeom prst="rect">
+            <a:avLst/>
+          </a:prstGeom>
+          <a:noFill/>
+        </p:spPr>
+        <p:txBody>
+          <a:bodyPr wrap="square">
+            <a:spAutoFit/>
+          </a:bodyPr>
+          <a:lstStyle/>
+          <a:p>
+            <a:pPr algn="ctr">
+              <a:defRPr sz="2200" b="1">
+                <a:solidFill>
+                  <a:srgbClr val="000000"/>
+                </a:solidFill>
+              </a:defRPr>
+            </a:pPr>
+            <a:r>
+              <a:t>Spring 2026 KSAS Conference</a:t>
+            </a:r>
+          </a:p>
+          <a:p>
+            <a:pPr algn="ctr">
+              <a:spcBef>
+                <a:spcPts val="600"/>
+              </a:spcBef>
+              <a:defRPr sz="1800" b="0">
+                <a:solidFill>
+                  <a:srgbClr val="666666"/>
+                </a:solidFill>
+              </a:defRPr>
+            </a:pPr>
+            <a:r>
+              <a:t>[Author Name] — [Affiliation]</a:t>
+            </a:r>
+          </a:p>
+        </p:txBody>
+      </p:sp>
+      <p:sp>
+        <p:nvSpPr>
+          <p:cNvPr id="6" name="TextBox 5"/>
+          <p:cNvSpPr txBox="1"/>
+          <p:nvPr/>
+        </p:nvSpPr>
+        <p:spPr>
+          <a:xfrm>
+            <a:off x="16642080" y="9646920"/>
+            <a:ext cx="1097280" cy="457200"/>
+          </a:xfrm>
+          <a:prstGeom prst="rect">
+            <a:avLst/>
+          </a:prstGeom>
+          <a:noFill/>
+        </p:spPr>
+        <p:txBody>
+          <a:bodyPr wrap="none">
+            <a:spAutoFit/>
+          </a:bodyPr>
+          <a:lstStyle/>
+          <a:p>
             <a:pPr algn="r">
               <a:defRPr sz="1400">
                 <a:solidFill>
@@ -3159,291 +3322,6 @@
             <a:r>
               <a:t>1/12</a:t>
             </a:r>
-          </a:p>
-        </p:txBody>
-      </p:sp>
-      <p:sp>
-        <p:nvSpPr>
-          <p:cNvPr id="7" name="TextBox 7">
-            <a:extLst>
-              <a:ext uri="{FF2B5EF4-FFF2-40B4-BE49-F238E27FC236}">
-                <a16:creationId xmlns:a16="http://schemas.microsoft.com/office/drawing/2014/main" id="{95CF4808-80C9-045E-4D77-981B982D8C1D}"/>
-              </a:ext>
-            </a:extLst>
-          </p:cNvPr>
-          <p:cNvSpPr txBox="1"/>
-          <p:nvPr/>
-        </p:nvSpPr>
-        <p:spPr>
-          <a:xfrm>
-            <a:off x="-1600200" y="4229100"/>
-            <a:ext cx="21564599" cy="1819729"/>
-          </a:xfrm>
-          <a:prstGeom prst="rect">
-            <a:avLst/>
-          </a:prstGeom>
-        </p:spPr>
-        <p:txBody>
-          <a:bodyPr wrap="square" lIns="0" tIns="0" rIns="0" bIns="0" rtlCol="0" anchor="t">
-            <a:spAutoFit/>
-          </a:bodyPr>
-          <a:lstStyle/>
-          <a:p>
-            <a:pPr marL="0" lvl="0" indent="0" algn="ctr">
-              <a:lnSpc>
-                <a:spcPts val="15400"/>
-              </a:lnSpc>
-              <a:spcBef>
-                <a:spcPct val="0"/>
-              </a:spcBef>
-            </a:pPr>
-            <a:r>
-              <a:rPr lang="en-US" sz="7200" b="1" spc="-220" dirty="0">
-                <a:solidFill>
-                  <a:srgbClr val="000000"/>
-                </a:solidFill>
-                <a:latin typeface="각진펜 Bold"/>
-                <a:ea typeface="각진펜 Bold"/>
-                <a:cs typeface="각진펜 Bold"/>
-                <a:sym typeface="각진펜 Bold"/>
-              </a:rPr>
-              <a:t>Flight Attitude-Control Validation</a:t>
-            </a:r>
-          </a:p>
-        </p:txBody>
-      </p:sp>
-      <p:sp>
-        <p:nvSpPr>
-          <p:cNvPr id="8" name="TextBox 8">
-            <a:extLst>
-              <a:ext uri="{FF2B5EF4-FFF2-40B4-BE49-F238E27FC236}">
-                <a16:creationId xmlns:a16="http://schemas.microsoft.com/office/drawing/2014/main" id="{C8E104A6-6EBE-8FDF-1228-001ED563A6D8}"/>
-              </a:ext>
-            </a:extLst>
-          </p:cNvPr>
-          <p:cNvSpPr txBox="1"/>
-          <p:nvPr/>
-        </p:nvSpPr>
-        <p:spPr>
-          <a:xfrm>
-            <a:off x="2023900" y="3238500"/>
-            <a:ext cx="14316398" cy="1410001"/>
-          </a:xfrm>
-          <a:prstGeom prst="rect">
-            <a:avLst/>
-          </a:prstGeom>
-        </p:spPr>
-        <p:txBody>
-          <a:bodyPr wrap="square" lIns="0" tIns="0" rIns="0" bIns="0" rtlCol="0" anchor="t">
-            <a:spAutoFit/>
-          </a:bodyPr>
-          <a:lstStyle/>
-          <a:p>
-            <a:pPr algn="ctr">
-              <a:lnSpc>
-                <a:spcPts val="12460"/>
-              </a:lnSpc>
-            </a:pPr>
-            <a:r>
-              <a:rPr lang="en-US" sz="5400" b="1" spc="-178" dirty="0">
-                <a:solidFill>
-                  <a:srgbClr val="004AAD"/>
-                </a:solidFill>
-                <a:latin typeface="각진펜 Bold"/>
-                <a:ea typeface="각진펜 Bold"/>
-                <a:cs typeface="각진펜 Bold"/>
-                <a:sym typeface="각진펜 Bold"/>
-              </a:rPr>
-              <a:t>Physically Closed-Loop HILS for</a:t>
-            </a:r>
-          </a:p>
-        </p:txBody>
-      </p:sp>
-      <p:sp>
-        <p:nvSpPr>
-          <p:cNvPr id="9" name="TextBox 9">
-            <a:extLst>
-              <a:ext uri="{FF2B5EF4-FFF2-40B4-BE49-F238E27FC236}">
-                <a16:creationId xmlns:a16="http://schemas.microsoft.com/office/drawing/2014/main" id="{15AC8D5D-0D25-57A6-051D-6F4475DFE344}"/>
-              </a:ext>
-            </a:extLst>
-          </p:cNvPr>
-          <p:cNvSpPr txBox="1"/>
-          <p:nvPr/>
-        </p:nvSpPr>
-        <p:spPr>
-          <a:xfrm>
-            <a:off x="4885350" y="6057900"/>
-            <a:ext cx="8517301" cy="382797"/>
-          </a:xfrm>
-          <a:prstGeom prst="rect">
-            <a:avLst/>
-          </a:prstGeom>
-        </p:spPr>
-        <p:txBody>
-          <a:bodyPr lIns="0" tIns="0" rIns="0" bIns="0" rtlCol="0" anchor="t">
-            <a:spAutoFit/>
-          </a:bodyPr>
-          <a:lstStyle/>
-          <a:p>
-            <a:pPr algn="ctr">
-              <a:lnSpc>
-                <a:spcPts val="3080"/>
-              </a:lnSpc>
-              <a:spcBef>
-                <a:spcPct val="0"/>
-              </a:spcBef>
-            </a:pPr>
-            <a:r>
-              <a:rPr lang="en-US" sz="2200" b="1" spc="-44" dirty="0">
-                <a:solidFill>
-                  <a:srgbClr val="000000"/>
-                </a:solidFill>
-                <a:latin typeface="각진펜 Bold"/>
-                <a:ea typeface="각진펜 Bold"/>
-                <a:cs typeface="각진펜 Bold"/>
-                <a:sym typeface="각진펜 Bold"/>
-              </a:rPr>
-              <a:t>Using a Stewart Platform with X-Plane and PX4</a:t>
-            </a:r>
-          </a:p>
-        </p:txBody>
-      </p:sp>
-      <p:sp>
-        <p:nvSpPr>
-          <p:cNvPr id="11" name="TextBox 10">
-            <a:extLst>
-              <a:ext uri="{FF2B5EF4-FFF2-40B4-BE49-F238E27FC236}">
-                <a16:creationId xmlns:a16="http://schemas.microsoft.com/office/drawing/2014/main" id="{5DF59840-C0D8-9420-4051-70C2293698B8}"/>
-              </a:ext>
-            </a:extLst>
-          </p:cNvPr>
-          <p:cNvSpPr txBox="1"/>
-          <p:nvPr/>
-        </p:nvSpPr>
-        <p:spPr>
-          <a:xfrm>
-            <a:off x="4885350" y="7837735"/>
-            <a:ext cx="8517301" cy="881652"/>
-          </a:xfrm>
-          <a:prstGeom prst="rect">
-            <a:avLst/>
-          </a:prstGeom>
-        </p:spPr>
-        <p:txBody>
-          <a:bodyPr lIns="0" tIns="0" rIns="0" bIns="0" rtlCol="0" anchor="t">
-            <a:spAutoFit/>
-          </a:bodyPr>
-          <a:lstStyle/>
-          <a:p>
-            <a:pPr algn="ctr">
-              <a:lnSpc>
-                <a:spcPts val="3499"/>
-              </a:lnSpc>
-              <a:spcBef>
-                <a:spcPct val="0"/>
-              </a:spcBef>
-            </a:pPr>
-            <a:r>
-              <a:rPr lang="en-US" sz="2499" b="1" spc="-49" dirty="0" err="1">
-                <a:solidFill>
-                  <a:srgbClr val="000000"/>
-                </a:solidFill>
-                <a:latin typeface="각진펜 Bold"/>
-                <a:ea typeface="각진펜 Bold"/>
-                <a:cs typeface="각진펜 Bold"/>
-                <a:sym typeface="각진펜 Bold"/>
-              </a:rPr>
-              <a:t>작성자</a:t>
-            </a:r>
-            <a:r>
-              <a:rPr lang="en-US" sz="2499" b="1" spc="-49" dirty="0">
-                <a:solidFill>
-                  <a:srgbClr val="000000"/>
-                </a:solidFill>
-                <a:latin typeface="각진펜 Bold"/>
-                <a:ea typeface="각진펜 Bold"/>
-                <a:cs typeface="각진펜 Bold"/>
-                <a:sym typeface="각진펜 Bold"/>
-              </a:rPr>
-              <a:t> : </a:t>
-            </a:r>
-            <a:r>
-              <a:rPr lang="ko-KR" altLang="en-US" sz="2499" b="1" spc="-49" dirty="0">
-                <a:solidFill>
-                  <a:srgbClr val="000000"/>
-                </a:solidFill>
-                <a:latin typeface="각진펜 Bold"/>
-                <a:ea typeface="각진펜 Bold"/>
-                <a:cs typeface="각진펜 Bold"/>
-                <a:sym typeface="각진펜 Bold"/>
-              </a:rPr>
-              <a:t>국민대 정현용 국민대 이수원</a:t>
-            </a:r>
-            <a:endParaRPr lang="en-US" altLang="ko-KR" sz="2499" b="1" spc="-49" dirty="0">
-              <a:solidFill>
-                <a:srgbClr val="000000"/>
-              </a:solidFill>
-              <a:latin typeface="각진펜 Bold"/>
-              <a:ea typeface="각진펜 Bold"/>
-              <a:cs typeface="각진펜 Bold"/>
-              <a:sym typeface="각진펜 Bold"/>
-            </a:endParaRPr>
-          </a:p>
-          <a:p>
-            <a:pPr algn="ctr">
-              <a:lnSpc>
-                <a:spcPts val="3499"/>
-              </a:lnSpc>
-              <a:spcBef>
-                <a:spcPct val="0"/>
-              </a:spcBef>
-            </a:pPr>
-            <a:r>
-              <a:rPr lang="ko-KR" altLang="en-US" sz="2499" b="1" spc="-49" dirty="0">
-                <a:solidFill>
-                  <a:srgbClr val="000000"/>
-                </a:solidFill>
-                <a:latin typeface="각진펜 Bold"/>
-                <a:ea typeface="각진펜 Bold"/>
-                <a:cs typeface="각진펜 Bold"/>
-                <a:sym typeface="각진펜 Bold"/>
-              </a:rPr>
-              <a:t>발표자</a:t>
-            </a:r>
-            <a:r>
-              <a:rPr lang="en-US" altLang="ko-KR" sz="2499" b="1" spc="-49" dirty="0">
-                <a:solidFill>
-                  <a:srgbClr val="000000"/>
-                </a:solidFill>
-                <a:latin typeface="각진펜 Bold"/>
-                <a:ea typeface="각진펜 Bold"/>
-                <a:cs typeface="각진펜 Bold"/>
-                <a:sym typeface="각진펜 Bold"/>
-              </a:rPr>
-              <a:t>:</a:t>
-            </a:r>
-            <a:r>
-              <a:rPr lang="ko-KR" altLang="en-US" sz="2499" b="1" spc="-49" dirty="0">
-                <a:solidFill>
-                  <a:srgbClr val="000000"/>
-                </a:solidFill>
-                <a:latin typeface="각진펜 Bold"/>
-                <a:ea typeface="각진펜 Bold"/>
-                <a:cs typeface="각진펜 Bold"/>
-                <a:sym typeface="각진펜 Bold"/>
-              </a:rPr>
-              <a:t> 국민대 정현용</a:t>
-            </a:r>
-            <a:endParaRPr lang="en-US" sz="2499" b="1" spc="-49" dirty="0">
-              <a:solidFill>
-                <a:srgbClr val="000000"/>
-              </a:solidFill>
-              <a:latin typeface="각진펜 Bold"/>
-              <a:ea typeface="각진펜 Bold"/>
-              <a:cs typeface="각진펜 Bold"/>
-              <a:sym typeface="각진펜 Bold"/>
-            </a:endParaRPr>
           </a:p>
         </p:txBody>
       </p:sp>
@@ -3456,7 +3334,7 @@
 </file>
 
 <file path=ppt/slides/slide10.xml><?xml version="1.0" encoding="utf-8"?>
-<p:sld xmlns:a="http://schemas.openxmlformats.org/drawingml/2006/main" xmlns:r="http://schemas.openxmlformats.org/officeDocument/2006/relationships" xmlns:p="http://schemas.openxmlformats.org/presentationml/2006/main">
+<p:sld xmlns:a="http://schemas.openxmlformats.org/drawingml/2006/main" xmlns:p="http://schemas.openxmlformats.org/presentationml/2006/main" xmlns:r="http://schemas.openxmlformats.org/officeDocument/2006/relationships">
   <p:cSld>
     <p:bg>
       <p:bgPr>
@@ -3472,14 +3350,7 @@
         <p:cNvGrpSpPr/>
         <p:nvPr/>
       </p:nvGrpSpPr>
-      <p:grpSpPr>
-        <a:xfrm>
-          <a:off x="0" y="0"/>
-          <a:ext cx="0" cy="0"/>
-          <a:chOff x="0" y="0"/>
-          <a:chExt cx="0" cy="0"/>
-        </a:xfrm>
-      </p:grpSpPr>
+      <p:grpSpPr/>
       <p:sp>
         <p:nvSpPr>
           <p:cNvPr id="2" name="Rectangle 1"/>
@@ -3521,7 +3392,6 @@
           <a:lstStyle/>
           <a:p>
             <a:pPr algn="ctr"/>
-            <a:endParaRPr/>
           </a:p>
         </p:txBody>
       </p:sp>
@@ -3566,7 +3436,6 @@
           <a:lstStyle/>
           <a:p>
             <a:pPr algn="ctr"/>
-            <a:endParaRPr/>
           </a:p>
         </p:txBody>
       </p:sp>
@@ -3646,7 +3515,6 @@
           <a:lstStyle/>
           <a:p>
             <a:pPr algn="ctr"/>
-            <a:endParaRPr/>
           </a:p>
         </p:txBody>
       </p:sp>
@@ -3800,7 +3668,6 @@
           <a:lstStyle/>
           <a:p>
             <a:pPr algn="ctr"/>
-            <a:endParaRPr/>
           </a:p>
         </p:txBody>
       </p:sp>
@@ -3954,7 +3821,6 @@
           <a:lstStyle/>
           <a:p>
             <a:pPr algn="ctr"/>
-            <a:endParaRPr/>
           </a:p>
         </p:txBody>
       </p:sp>
@@ -4108,7 +3974,6 @@
           <a:lstStyle/>
           <a:p>
             <a:pPr algn="ctr"/>
-            <a:endParaRPr/>
           </a:p>
         </p:txBody>
       </p:sp>
@@ -4262,7 +4127,6 @@
           <a:lstStyle/>
           <a:p>
             <a:pPr algn="ctr"/>
-            <a:endParaRPr/>
           </a:p>
         </p:txBody>
       </p:sp>
@@ -4345,7 +4209,7 @@
 </file>
 
 <file path=ppt/slides/slide11.xml><?xml version="1.0" encoding="utf-8"?>
-<p:sld xmlns:a="http://schemas.openxmlformats.org/drawingml/2006/main" xmlns:r="http://schemas.openxmlformats.org/officeDocument/2006/relationships" xmlns:p="http://schemas.openxmlformats.org/presentationml/2006/main">
+<p:sld xmlns:a="http://schemas.openxmlformats.org/drawingml/2006/main" xmlns:p="http://schemas.openxmlformats.org/presentationml/2006/main" xmlns:r="http://schemas.openxmlformats.org/officeDocument/2006/relationships">
   <p:cSld>
     <p:bg>
       <p:bgPr>
@@ -4361,14 +4225,7 @@
         <p:cNvGrpSpPr/>
         <p:nvPr/>
       </p:nvGrpSpPr>
-      <p:grpSpPr>
-        <a:xfrm>
-          <a:off x="0" y="0"/>
-          <a:ext cx="0" cy="0"/>
-          <a:chOff x="0" y="0"/>
-          <a:chExt cx="0" cy="0"/>
-        </a:xfrm>
-      </p:grpSpPr>
+      <p:grpSpPr/>
       <p:sp>
         <p:nvSpPr>
           <p:cNvPr id="2" name="Rectangle 1"/>
@@ -4410,7 +4267,6 @@
           <a:lstStyle/>
           <a:p>
             <a:pPr algn="ctr"/>
-            <a:endParaRPr/>
           </a:p>
         </p:txBody>
       </p:sp>
@@ -4455,7 +4311,6 @@
           <a:lstStyle/>
           <a:p>
             <a:pPr algn="ctr"/>
-            <a:endParaRPr/>
           </a:p>
         </p:txBody>
       </p:sp>
@@ -4686,7 +4541,6 @@
           <a:lstStyle/>
           <a:p>
             <a:pPr algn="ctr"/>
-            <a:endParaRPr/>
           </a:p>
         </p:txBody>
       </p:sp>
@@ -4879,7 +4733,6 @@
           <a:lstStyle/>
           <a:p>
             <a:pPr algn="ctr"/>
-            <a:endParaRPr/>
           </a:p>
         </p:txBody>
       </p:sp>
@@ -4977,7 +4830,7 @@
 </file>
 
 <file path=ppt/slides/slide12.xml><?xml version="1.0" encoding="utf-8"?>
-<p:sld xmlns:a="http://schemas.openxmlformats.org/drawingml/2006/main" xmlns:r="http://schemas.openxmlformats.org/officeDocument/2006/relationships" xmlns:p="http://schemas.openxmlformats.org/presentationml/2006/main">
+<p:sld xmlns:a="http://schemas.openxmlformats.org/drawingml/2006/main" xmlns:p="http://schemas.openxmlformats.org/presentationml/2006/main" xmlns:r="http://schemas.openxmlformats.org/officeDocument/2006/relationships">
   <p:cSld>
     <p:bg>
       <p:bgPr>
@@ -4993,14 +4846,7 @@
         <p:cNvGrpSpPr/>
         <p:nvPr/>
       </p:nvGrpSpPr>
-      <p:grpSpPr>
-        <a:xfrm>
-          <a:off x="0" y="0"/>
-          <a:ext cx="0" cy="0"/>
-          <a:chOff x="0" y="0"/>
-          <a:chExt cx="0" cy="0"/>
-        </a:xfrm>
-      </p:grpSpPr>
+      <p:grpSpPr/>
       <p:sp>
         <p:nvSpPr>
           <p:cNvPr id="2" name="Rectangle 1"/>
@@ -5042,7 +4888,6 @@
           <a:lstStyle/>
           <a:p>
             <a:pPr algn="ctr"/>
-            <a:endParaRPr/>
           </a:p>
         </p:txBody>
       </p:sp>
@@ -5087,7 +4932,6 @@
           <a:lstStyle/>
           <a:p>
             <a:pPr algn="ctr"/>
-            <a:endParaRPr/>
           </a:p>
         </p:txBody>
       </p:sp>
@@ -5649,7 +5493,7 @@
 </file>
 
 <file path=ppt/slides/slide2.xml><?xml version="1.0" encoding="utf-8"?>
-<p:sld xmlns:a="http://schemas.openxmlformats.org/drawingml/2006/main" xmlns:r="http://schemas.openxmlformats.org/officeDocument/2006/relationships" xmlns:p="http://schemas.openxmlformats.org/presentationml/2006/main">
+<p:sld xmlns:a="http://schemas.openxmlformats.org/drawingml/2006/main" xmlns:p="http://schemas.openxmlformats.org/presentationml/2006/main" xmlns:r="http://schemas.openxmlformats.org/officeDocument/2006/relationships">
   <p:cSld>
     <p:bg>
       <p:bgPr>
@@ -5665,14 +5509,7 @@
         <p:cNvGrpSpPr/>
         <p:nvPr/>
       </p:nvGrpSpPr>
-      <p:grpSpPr>
-        <a:xfrm>
-          <a:off x="0" y="0"/>
-          <a:ext cx="0" cy="0"/>
-          <a:chOff x="0" y="0"/>
-          <a:chExt cx="0" cy="0"/>
-        </a:xfrm>
-      </p:grpSpPr>
+      <p:grpSpPr/>
       <p:sp>
         <p:nvSpPr>
           <p:cNvPr id="2" name="Rectangle 1"/>
@@ -5714,7 +5551,6 @@
           <a:lstStyle/>
           <a:p>
             <a:pPr algn="ctr"/>
-            <a:endParaRPr/>
           </a:p>
         </p:txBody>
       </p:sp>
@@ -5759,7 +5595,6 @@
           <a:lstStyle/>
           <a:p>
             <a:pPr algn="ctr"/>
-            <a:endParaRPr/>
           </a:p>
         </p:txBody>
       </p:sp>
@@ -5815,57 +5650,11 @@
           <a:noFill/>
         </p:spPr>
         <p:txBody>
-          <a:bodyPr wrap="square"/>
-          <a:lstStyle/>
-          <a:p>
-            <a:pPr algn="ctr">
-              <a:defRPr sz="1600" b="0">
-                <a:solidFill>
-                  <a:srgbClr val="999999"/>
-                </a:solidFill>
-              </a:defRPr>
-            </a:pPr>
-            <a:r>
-              <a:rPr dirty="0" err="1"/>
-              <a:t>왜</a:t>
-            </a:r>
-            <a:r>
-              <a:rPr dirty="0"/>
-              <a:t> </a:t>
-            </a:r>
-            <a:r>
-              <a:rPr dirty="0" err="1"/>
-              <a:t>HILS에</a:t>
-            </a:r>
-            <a:r>
-              <a:rPr dirty="0"/>
-              <a:t> </a:t>
-            </a:r>
-            <a:r>
-              <a:rPr dirty="0" err="1"/>
-              <a:t>물리적</a:t>
-            </a:r>
-            <a:r>
-              <a:rPr dirty="0"/>
-              <a:t> </a:t>
-            </a:r>
-            <a:r>
-              <a:rPr dirty="0" err="1"/>
-              <a:t>모션이</a:t>
-            </a:r>
-            <a:r>
-              <a:rPr dirty="0"/>
-              <a:t> </a:t>
-            </a:r>
-            <a:r>
-              <a:rPr dirty="0" err="1"/>
-              <a:t>필요한가</a:t>
-            </a:r>
-            <a:r>
-              <a:rPr dirty="0"/>
-              <a:t>?</a:t>
-            </a:r>
-          </a:p>
+          <a:bodyPr wrap="none">
+            <a:spAutoFit/>
+          </a:bodyPr>
+          <a:lstStyle/>
+          <a:p/>
         </p:txBody>
       </p:sp>
       <p:sp>
@@ -5898,8 +5687,22 @@
               </a:defRPr>
             </a:pPr>
             <a:r>
-              <a:rPr dirty="0"/>
               <a:t>Conventional HILS</a:t>
+            </a:r>
+          </a:p>
+          <a:p>
+            <a:pPr algn="l">
+              <a:spcBef>
+                <a:spcPts val="1400"/>
+              </a:spcBef>
+              <a:defRPr sz="2000" b="0">
+                <a:solidFill>
+                  <a:srgbClr val="2D2D2D"/>
+                </a:solidFill>
+              </a:defRPr>
+            </a:pPr>
+            <a:r>
+              <a:t>•  Simulator computes dynamics</a:t>
             </a:r>
           </a:p>
           <a:p>
@@ -5914,12 +5717,7 @@
               </a:defRPr>
             </a:pPr>
             <a:r>
-              <a:rPr lang="ko-KR" altLang="en-US" dirty="0"/>
-              <a:t>기존 </a:t>
-            </a:r>
-            <a:r>
-              <a:rPr lang="en-US" dirty="0"/>
-              <a:t>HILS</a:t>
+              <a:t>    시뮬레이터가 동역학 계산</a:t>
             </a:r>
           </a:p>
           <a:p>
@@ -5934,8 +5732,7 @@
               </a:defRPr>
             </a:pPr>
             <a:r>
-              <a:rPr dirty="0"/>
-              <a:t>•  Simulator computes dynamics</a:t>
+              <a:t>•  Controller receives synthetic sensor signals</a:t>
             </a:r>
           </a:p>
           <a:p>
@@ -5950,30 +5747,8 @@
               </a:defRPr>
             </a:pPr>
             <a:r>
-              <a:rPr dirty="0"/>
-              <a:t>    </a:t>
-            </a:r>
-            <a:r>
-              <a:rPr dirty="0" err="1"/>
-              <a:t>시뮬레이터가</a:t>
-            </a:r>
-            <a:r>
-              <a:rPr dirty="0"/>
-              <a:t> </a:t>
-            </a:r>
-            <a:r>
-              <a:rPr dirty="0" err="1"/>
-              <a:t>동역학</a:t>
-            </a:r>
-            <a:r>
-              <a:rPr dirty="0"/>
-              <a:t> </a:t>
-            </a:r>
-            <a:r>
-              <a:rPr dirty="0" err="1"/>
-              <a:t>계산</a:t>
-            </a:r>
-            <a:endParaRPr dirty="0"/>
+              <a:t>    합성 센서 신호 수신</a:t>
+            </a:r>
           </a:p>
           <a:p>
             <a:pPr algn="l">
@@ -5987,8 +5762,7 @@
               </a:defRPr>
             </a:pPr>
             <a:r>
-              <a:rPr dirty="0"/>
-              <a:t>•  Controller receives synthetic sensor signals</a:t>
+              <a:t>•  Attitude evaluated via logs / screens</a:t>
             </a:r>
           </a:p>
           <a:p>
@@ -6003,38 +5777,8 @@
               </a:defRPr>
             </a:pPr>
             <a:r>
-              <a:rPr dirty="0"/>
-              <a:t>    </a:t>
-            </a:r>
-            <a:r>
-              <a:rPr dirty="0" err="1"/>
-              <a:t>합성</a:t>
-            </a:r>
-            <a:r>
-              <a:rPr dirty="0"/>
-              <a:t> </a:t>
-            </a:r>
-            <a:r>
-              <a:rPr dirty="0" err="1"/>
-              <a:t>센서</a:t>
-            </a:r>
-            <a:r>
-              <a:rPr dirty="0"/>
-              <a:t> </a:t>
-            </a:r>
-            <a:r>
-              <a:rPr dirty="0" err="1"/>
-              <a:t>신호</a:t>
-            </a:r>
-            <a:r>
-              <a:rPr dirty="0"/>
-              <a:t> </a:t>
-            </a:r>
-            <a:r>
-              <a:rPr dirty="0" err="1"/>
-              <a:t>수신</a:t>
-            </a:r>
-            <a:endParaRPr dirty="0"/>
+              <a:t>    로그/화면으로만 자세 확인</a:t>
+            </a:r>
           </a:p>
           <a:p>
             <a:pPr algn="l">
@@ -6048,8 +5792,7 @@
               </a:defRPr>
             </a:pPr>
             <a:r>
-              <a:rPr dirty="0"/>
-              <a:t>•  Attitude evaluated via logs / screens</a:t>
+              <a:t>•  IMU does not experience real motion</a:t>
             </a:r>
           </a:p>
           <a:p>
@@ -6064,38 +5807,43 @@
               </a:defRPr>
             </a:pPr>
             <a:r>
-              <a:rPr dirty="0"/>
-              <a:t>    </a:t>
-            </a:r>
-            <a:r>
-              <a:rPr dirty="0" err="1"/>
-              <a:t>로그</a:t>
-            </a:r>
-            <a:r>
-              <a:rPr dirty="0"/>
-              <a:t>/</a:t>
-            </a:r>
-            <a:r>
-              <a:rPr dirty="0" err="1"/>
-              <a:t>화면으로만</a:t>
-            </a:r>
-            <a:r>
-              <a:rPr dirty="0"/>
-              <a:t> </a:t>
-            </a:r>
-            <a:r>
-              <a:rPr dirty="0" err="1"/>
-              <a:t>자세</a:t>
-            </a:r>
-            <a:r>
-              <a:rPr dirty="0"/>
-              <a:t> </a:t>
-            </a:r>
-            <a:r>
-              <a:rPr dirty="0" err="1"/>
-              <a:t>확인</a:t>
-            </a:r>
-            <a:endParaRPr dirty="0"/>
+              <a:t>    IMU가 실제 관성 운동 미경험</a:t>
+            </a:r>
+          </a:p>
+        </p:txBody>
+      </p:sp>
+      <p:sp>
+        <p:nvSpPr>
+          <p:cNvPr id="7" name="TextBox 6"/>
+          <p:cNvSpPr txBox="1"/>
+          <p:nvPr/>
+        </p:nvSpPr>
+        <p:spPr>
+          <a:xfrm>
+            <a:off x="9784080" y="3108960"/>
+            <a:ext cx="6858000" cy="5029200"/>
+          </a:xfrm>
+          <a:prstGeom prst="rect">
+            <a:avLst/>
+          </a:prstGeom>
+          <a:noFill/>
+        </p:spPr>
+        <p:txBody>
+          <a:bodyPr wrap="square">
+            <a:spAutoFit/>
+          </a:bodyPr>
+          <a:lstStyle/>
+          <a:p>
+            <a:pPr>
+              <a:defRPr sz="2800" b="1">
+                <a:solidFill>
+                  <a:srgbClr val="004AAD"/>
+                </a:solidFill>
+              </a:defRPr>
+            </a:pPr>
+            <a:r>
+              <a:t>This Work</a:t>
+            </a:r>
           </a:p>
           <a:p>
             <a:pPr algn="l">
@@ -6109,8 +5857,7 @@
               </a:defRPr>
             </a:pPr>
             <a:r>
-              <a:rPr dirty="0"/>
-              <a:t>•  IMU does not experience real motion</a:t>
+              <a:t>•  Simulator drives real Stewart platform motion</a:t>
             </a:r>
           </a:p>
           <a:p>
@@ -6125,81 +5872,22 @@
               </a:defRPr>
             </a:pPr>
             <a:r>
-              <a:rPr dirty="0"/>
-              <a:t>    </a:t>
-            </a:r>
-            <a:r>
-              <a:rPr dirty="0" err="1"/>
-              <a:t>IMU가</a:t>
-            </a:r>
-            <a:r>
-              <a:rPr dirty="0"/>
-              <a:t> </a:t>
-            </a:r>
-            <a:r>
-              <a:rPr dirty="0" err="1"/>
-              <a:t>실제</a:t>
-            </a:r>
-            <a:r>
-              <a:rPr dirty="0"/>
-              <a:t> </a:t>
-            </a:r>
-            <a:r>
-              <a:rPr dirty="0" err="1"/>
-              <a:t>관성</a:t>
-            </a:r>
-            <a:r>
-              <a:rPr dirty="0"/>
-              <a:t> </a:t>
-            </a:r>
-            <a:r>
-              <a:rPr dirty="0" err="1"/>
-              <a:t>운동</a:t>
-            </a:r>
-            <a:r>
-              <a:rPr dirty="0"/>
-              <a:t> </a:t>
-            </a:r>
-            <a:r>
-              <a:rPr dirty="0" err="1"/>
-              <a:t>미경험</a:t>
-            </a:r>
-            <a:endParaRPr dirty="0"/>
-          </a:p>
-        </p:txBody>
-      </p:sp>
-      <p:sp>
-        <p:nvSpPr>
-          <p:cNvPr id="7" name="TextBox 6"/>
-          <p:cNvSpPr txBox="1"/>
-          <p:nvPr/>
-        </p:nvSpPr>
-        <p:spPr>
-          <a:xfrm>
-            <a:off x="9784080" y="3108960"/>
-            <a:ext cx="6858000" cy="5029200"/>
-          </a:xfrm>
-          <a:prstGeom prst="rect">
-            <a:avLst/>
-          </a:prstGeom>
-          <a:noFill/>
-        </p:spPr>
-        <p:txBody>
-          <a:bodyPr wrap="square">
-            <a:spAutoFit/>
-          </a:bodyPr>
-          <a:lstStyle/>
-          <a:p>
-            <a:pPr>
-              <a:defRPr sz="2800" b="1">
-                <a:solidFill>
-                  <a:srgbClr val="004AAD"/>
-                </a:solidFill>
-              </a:defRPr>
-            </a:pPr>
-            <a:r>
-              <a:rPr dirty="0"/>
-              <a:t>This Work</a:t>
+              <a:t>    실제 플랫폼 모션 구동</a:t>
+            </a:r>
+          </a:p>
+          <a:p>
+            <a:pPr algn="l">
+              <a:spcBef>
+                <a:spcPts val="1400"/>
+              </a:spcBef>
+              <a:defRPr sz="2000" b="0">
+                <a:solidFill>
+                  <a:srgbClr val="2D2D2D"/>
+                </a:solidFill>
+              </a:defRPr>
+            </a:pPr>
+            <a:r>
+              <a:t>•  PX4 IMU senses real inertial excitation</a:t>
             </a:r>
           </a:p>
           <a:p>
@@ -6214,18 +5902,8 @@
               </a:defRPr>
             </a:pPr>
             <a:r>
-              <a:rPr dirty="0" err="1"/>
-              <a:t>본</a:t>
-            </a:r>
-            <a:r>
-              <a:rPr dirty="0"/>
-              <a:t> </a:t>
-            </a:r>
-            <a:r>
-              <a:rPr dirty="0" err="1"/>
-              <a:t>연구</a:t>
-            </a:r>
-            <a:endParaRPr dirty="0"/>
+              <a:t>    PX4 IMU 실제 관성 자극 감지</a:t>
+            </a:r>
           </a:p>
           <a:p>
             <a:pPr algn="l">
@@ -6239,8 +5917,7 @@
               </a:defRPr>
             </a:pPr>
             <a:r>
-              <a:rPr dirty="0"/>
-              <a:t>•  Simulator drives real Stewart platform motion</a:t>
+              <a:t>•  Measured attitude fed back into loop</a:t>
             </a:r>
           </a:p>
           <a:p>
@@ -6255,38 +5932,8 @@
               </a:defRPr>
             </a:pPr>
             <a:r>
-              <a:rPr dirty="0"/>
-              <a:t>    </a:t>
-            </a:r>
-            <a:r>
-              <a:rPr dirty="0" err="1"/>
-              <a:t>실제</a:t>
-            </a:r>
-            <a:r>
-              <a:rPr dirty="0"/>
-              <a:t> </a:t>
-            </a:r>
-            <a:r>
-              <a:rPr dirty="0" err="1"/>
-              <a:t>플랫폼</a:t>
-            </a:r>
-            <a:r>
-              <a:rPr dirty="0"/>
-              <a:t> </a:t>
-            </a:r>
-            <a:r>
-              <a:rPr dirty="0" err="1"/>
-              <a:t>모션</a:t>
-            </a:r>
-            <a:r>
-              <a:rPr dirty="0"/>
-              <a:t> </a:t>
-            </a:r>
-            <a:r>
-              <a:rPr dirty="0" err="1"/>
-              <a:t>구동</a:t>
-            </a:r>
-            <a:endParaRPr dirty="0"/>
+              <a:t>    측정 자세 → 제어 루프 피드백</a:t>
+            </a:r>
           </a:p>
           <a:p>
             <a:pPr algn="l">
@@ -6300,8 +5947,7 @@
               </a:defRPr>
             </a:pPr>
             <a:r>
-              <a:rPr dirty="0"/>
-              <a:t>•  PX4 IMU senses real inertial excitation</a:t>
+              <a:t>•  Timing and fidelity measured</a:t>
             </a:r>
           </a:p>
           <a:p>
@@ -6316,160 +5962,8 @@
               </a:defRPr>
             </a:pPr>
             <a:r>
-              <a:rPr dirty="0"/>
-              <a:t>    PX4 IMU </a:t>
-            </a:r>
-            <a:r>
-              <a:rPr dirty="0" err="1"/>
-              <a:t>실제</a:t>
-            </a:r>
-            <a:r>
-              <a:rPr dirty="0"/>
-              <a:t> </a:t>
-            </a:r>
-            <a:r>
-              <a:rPr dirty="0" err="1"/>
-              <a:t>관성</a:t>
-            </a:r>
-            <a:r>
-              <a:rPr dirty="0"/>
-              <a:t> </a:t>
-            </a:r>
-            <a:r>
-              <a:rPr dirty="0" err="1"/>
-              <a:t>자극</a:t>
-            </a:r>
-            <a:r>
-              <a:rPr dirty="0"/>
-              <a:t> </a:t>
-            </a:r>
-            <a:r>
-              <a:rPr dirty="0" err="1"/>
-              <a:t>감지</a:t>
-            </a:r>
-            <a:endParaRPr dirty="0"/>
-          </a:p>
-          <a:p>
-            <a:pPr algn="l">
-              <a:spcBef>
-                <a:spcPts val="1400"/>
-              </a:spcBef>
-              <a:defRPr sz="2000" b="0">
-                <a:solidFill>
-                  <a:srgbClr val="2D2D2D"/>
-                </a:solidFill>
-              </a:defRPr>
-            </a:pPr>
-            <a:r>
-              <a:rPr dirty="0"/>
-              <a:t>•  Measured attitude fed back into loop</a:t>
-            </a:r>
-          </a:p>
-          <a:p>
-            <a:pPr algn="l">
-              <a:spcBef>
-                <a:spcPts val="200"/>
-              </a:spcBef>
-              <a:defRPr sz="1600" b="0">
-                <a:solidFill>
-                  <a:srgbClr val="999999"/>
-                </a:solidFill>
-              </a:defRPr>
-            </a:pPr>
-            <a:r>
-              <a:rPr dirty="0"/>
-              <a:t>    </a:t>
-            </a:r>
-            <a:r>
-              <a:rPr dirty="0" err="1"/>
-              <a:t>측정</a:t>
-            </a:r>
-            <a:r>
-              <a:rPr dirty="0"/>
-              <a:t> </a:t>
-            </a:r>
-            <a:r>
-              <a:rPr dirty="0" err="1"/>
-              <a:t>자세</a:t>
-            </a:r>
-            <a:r>
-              <a:rPr dirty="0"/>
-              <a:t> → </a:t>
-            </a:r>
-            <a:r>
-              <a:rPr dirty="0" err="1"/>
-              <a:t>제어</a:t>
-            </a:r>
-            <a:r>
-              <a:rPr dirty="0"/>
-              <a:t> </a:t>
-            </a:r>
-            <a:r>
-              <a:rPr dirty="0" err="1"/>
-              <a:t>루프</a:t>
-            </a:r>
-            <a:r>
-              <a:rPr dirty="0"/>
-              <a:t> </a:t>
-            </a:r>
-            <a:r>
-              <a:rPr dirty="0" err="1"/>
-              <a:t>피드백</a:t>
-            </a:r>
-            <a:endParaRPr dirty="0"/>
-          </a:p>
-          <a:p>
-            <a:pPr algn="l">
-              <a:spcBef>
-                <a:spcPts val="1400"/>
-              </a:spcBef>
-              <a:defRPr sz="2000" b="0">
-                <a:solidFill>
-                  <a:srgbClr val="2D2D2D"/>
-                </a:solidFill>
-              </a:defRPr>
-            </a:pPr>
-            <a:r>
-              <a:rPr dirty="0"/>
-              <a:t>•  Timing and fidelity measured</a:t>
-            </a:r>
-          </a:p>
-          <a:p>
-            <a:pPr algn="l">
-              <a:spcBef>
-                <a:spcPts val="200"/>
-              </a:spcBef>
-              <a:defRPr sz="1600" b="0">
-                <a:solidFill>
-                  <a:srgbClr val="999999"/>
-                </a:solidFill>
-              </a:defRPr>
-            </a:pPr>
-            <a:r>
-              <a:rPr dirty="0"/>
-              <a:t>    </a:t>
-            </a:r>
-            <a:r>
-              <a:rPr dirty="0" err="1"/>
-              <a:t>타이밍·충실도</a:t>
-            </a:r>
-            <a:r>
-              <a:rPr dirty="0"/>
-              <a:t> </a:t>
-            </a:r>
-            <a:r>
-              <a:rPr dirty="0" err="1"/>
-              <a:t>정량</a:t>
-            </a:r>
-            <a:r>
-              <a:rPr dirty="0"/>
-              <a:t> </a:t>
-            </a:r>
-            <a:r>
-              <a:rPr dirty="0" err="1"/>
-              <a:t>측정</a:t>
-            </a:r>
-            <a:endParaRPr dirty="0"/>
+              <a:t>    타이밍·충실도 정량 측정</a:t>
+            </a:r>
           </a:p>
         </p:txBody>
       </p:sp>
@@ -6513,7 +6007,6 @@
           <a:lstStyle/>
           <a:p>
             <a:pPr algn="ctr"/>
-            <a:endParaRPr/>
           </a:p>
         </p:txBody>
       </p:sp>
@@ -6558,7 +6051,6 @@
           <a:lstStyle/>
           <a:p>
             <a:pPr algn="ctr"/>
-            <a:endParaRPr/>
           </a:p>
         </p:txBody>
       </p:sp>
@@ -6641,7 +6133,7 @@
 </file>
 
 <file path=ppt/slides/slide3.xml><?xml version="1.0" encoding="utf-8"?>
-<p:sld xmlns:a="http://schemas.openxmlformats.org/drawingml/2006/main" xmlns:r="http://schemas.openxmlformats.org/officeDocument/2006/relationships" xmlns:p="http://schemas.openxmlformats.org/presentationml/2006/main">
+<p:sld xmlns:a="http://schemas.openxmlformats.org/drawingml/2006/main" xmlns:p="http://schemas.openxmlformats.org/presentationml/2006/main" xmlns:r="http://schemas.openxmlformats.org/officeDocument/2006/relationships">
   <p:cSld>
     <p:bg>
       <p:bgPr>
@@ -6657,14 +6149,7 @@
         <p:cNvGrpSpPr/>
         <p:nvPr/>
       </p:nvGrpSpPr>
-      <p:grpSpPr>
-        <a:xfrm>
-          <a:off x="0" y="0"/>
-          <a:ext cx="0" cy="0"/>
-          <a:chOff x="0" y="0"/>
-          <a:chExt cx="0" cy="0"/>
-        </a:xfrm>
-      </p:grpSpPr>
+      <p:grpSpPr/>
       <p:sp>
         <p:nvSpPr>
           <p:cNvPr id="2" name="Rectangle 1"/>
@@ -6706,7 +6191,6 @@
           <a:lstStyle/>
           <a:p>
             <a:pPr algn="ctr"/>
-            <a:endParaRPr/>
           </a:p>
         </p:txBody>
       </p:sp>
@@ -6751,7 +6235,6 @@
           <a:lstStyle/>
           <a:p>
             <a:pPr algn="ctr"/>
-            <a:endParaRPr/>
           </a:p>
         </p:txBody>
       </p:sp>
@@ -7253,7 +6736,6 @@
           <a:lstStyle/>
           <a:p>
             <a:pPr algn="ctr"/>
-            <a:endParaRPr/>
           </a:p>
         </p:txBody>
       </p:sp>
@@ -7336,7 +6818,7 @@
 </file>
 
 <file path=ppt/slides/slide4.xml><?xml version="1.0" encoding="utf-8"?>
-<p:sld xmlns:a="http://schemas.openxmlformats.org/drawingml/2006/main" xmlns:r="http://schemas.openxmlformats.org/officeDocument/2006/relationships" xmlns:p="http://schemas.openxmlformats.org/presentationml/2006/main">
+<p:sld xmlns:a="http://schemas.openxmlformats.org/drawingml/2006/main" xmlns:p="http://schemas.openxmlformats.org/presentationml/2006/main" xmlns:r="http://schemas.openxmlformats.org/officeDocument/2006/relationships">
   <p:cSld>
     <p:bg>
       <p:bgPr>
@@ -7352,14 +6834,7 @@
         <p:cNvGrpSpPr/>
         <p:nvPr/>
       </p:nvGrpSpPr>
-      <p:grpSpPr>
-        <a:xfrm>
-          <a:off x="0" y="0"/>
-          <a:ext cx="0" cy="0"/>
-          <a:chOff x="0" y="0"/>
-          <a:chExt cx="0" cy="0"/>
-        </a:xfrm>
-      </p:grpSpPr>
+      <p:grpSpPr/>
       <p:sp>
         <p:nvSpPr>
           <p:cNvPr id="2" name="Rectangle 1"/>
@@ -7401,7 +6876,6 @@
           <a:lstStyle/>
           <a:p>
             <a:pPr algn="ctr"/>
-            <a:endParaRPr/>
           </a:p>
         </p:txBody>
       </p:sp>
@@ -7446,7 +6920,6 @@
           <a:lstStyle/>
           <a:p>
             <a:pPr algn="ctr"/>
-            <a:endParaRPr/>
           </a:p>
         </p:txBody>
       </p:sp>
@@ -7524,7 +6997,7 @@
           </a:fontRef>
         </p:style>
         <p:txBody>
-          <a:bodyPr wrap="square" lIns="254000" tIns="1828800" rtlCol="0" anchor="ctr"/>
+          <a:bodyPr rtlCol="0" anchor="ctr" wrap="square" tIns="1828800" lIns="254000"/>
           <a:lstStyle/>
           <a:p>
             <a:pPr algn="ctr">
@@ -7594,7 +7067,7 @@
           </a:fontRef>
         </p:style>
         <p:txBody>
-          <a:bodyPr wrap="square" lIns="254000" tIns="1828800" rtlCol="0" anchor="ctr"/>
+          <a:bodyPr rtlCol="0" anchor="ctr" wrap="square" tIns="1828800" lIns="254000"/>
           <a:lstStyle/>
           <a:p>
             <a:pPr algn="ctr">
@@ -7666,7 +7139,6 @@
           <a:lstStyle/>
           <a:p>
             <a:pPr algn="ctr"/>
-            <a:endParaRPr/>
           </a:p>
         </p:txBody>
       </p:sp>
@@ -7749,7 +7221,7 @@
 </file>
 
 <file path=ppt/slides/slide5.xml><?xml version="1.0" encoding="utf-8"?>
-<p:sld xmlns:a="http://schemas.openxmlformats.org/drawingml/2006/main" xmlns:r="http://schemas.openxmlformats.org/officeDocument/2006/relationships" xmlns:p="http://schemas.openxmlformats.org/presentationml/2006/main">
+<p:sld xmlns:a="http://schemas.openxmlformats.org/drawingml/2006/main" xmlns:p="http://schemas.openxmlformats.org/presentationml/2006/main" xmlns:r="http://schemas.openxmlformats.org/officeDocument/2006/relationships">
   <p:cSld>
     <p:bg>
       <p:bgPr>
@@ -7765,14 +7237,7 @@
         <p:cNvGrpSpPr/>
         <p:nvPr/>
       </p:nvGrpSpPr>
-      <p:grpSpPr>
-        <a:xfrm>
-          <a:off x="0" y="0"/>
-          <a:ext cx="0" cy="0"/>
-          <a:chOff x="0" y="0"/>
-          <a:chExt cx="0" cy="0"/>
-        </a:xfrm>
-      </p:grpSpPr>
+      <p:grpSpPr/>
       <p:sp>
         <p:nvSpPr>
           <p:cNvPr id="2" name="Rectangle 1"/>
@@ -7814,7 +7279,6 @@
           <a:lstStyle/>
           <a:p>
             <a:pPr algn="ctr"/>
-            <a:endParaRPr/>
           </a:p>
         </p:txBody>
       </p:sp>
@@ -7859,7 +7323,6 @@
           <a:lstStyle/>
           <a:p>
             <a:pPr algn="ctr"/>
-            <a:endParaRPr/>
           </a:p>
         </p:txBody>
       </p:sp>
@@ -7961,7 +7424,7 @@
           </a:fontRef>
         </p:style>
         <p:txBody>
-          <a:bodyPr wrap="square" lIns="0" tIns="25400" rIns="0" rtlCol="0" anchor="ctr"/>
+          <a:bodyPr rtlCol="0" anchor="ctr" wrap="square" tIns="25400" lIns="0" rIns="0"/>
           <a:lstStyle/>
           <a:p>
             <a:pPr algn="ctr">
@@ -8016,7 +7479,7 @@
           </a:fontRef>
         </p:style>
         <p:txBody>
-          <a:bodyPr wrap="square" lIns="0" tIns="25400" rIns="0" rtlCol="0" anchor="ctr"/>
+          <a:bodyPr rtlCol="0" anchor="ctr" wrap="square" tIns="25400" lIns="0" rIns="0"/>
           <a:lstStyle/>
           <a:p>
             <a:pPr algn="ctr">
@@ -8071,7 +7534,7 @@
           </a:fontRef>
         </p:style>
         <p:txBody>
-          <a:bodyPr wrap="square" lIns="0" tIns="25400" rIns="0" rtlCol="0" anchor="ctr"/>
+          <a:bodyPr rtlCol="0" anchor="ctr" wrap="square" tIns="25400" lIns="0" rIns="0"/>
           <a:lstStyle/>
           <a:p>
             <a:pPr algn="ctr">
@@ -8126,7 +7589,7 @@
           </a:fontRef>
         </p:style>
         <p:txBody>
-          <a:bodyPr wrap="square" lIns="0" tIns="25400" rIns="0" rtlCol="0" anchor="ctr"/>
+          <a:bodyPr rtlCol="0" anchor="ctr" wrap="square" tIns="25400" lIns="0" rIns="0"/>
           <a:lstStyle/>
           <a:p>
             <a:pPr algn="ctr">
@@ -8589,7 +8052,7 @@
 </file>
 
 <file path=ppt/slides/slide6.xml><?xml version="1.0" encoding="utf-8"?>
-<p:sld xmlns:a="http://schemas.openxmlformats.org/drawingml/2006/main" xmlns:r="http://schemas.openxmlformats.org/officeDocument/2006/relationships" xmlns:p="http://schemas.openxmlformats.org/presentationml/2006/main">
+<p:sld xmlns:a="http://schemas.openxmlformats.org/drawingml/2006/main" xmlns:p="http://schemas.openxmlformats.org/presentationml/2006/main" xmlns:r="http://schemas.openxmlformats.org/officeDocument/2006/relationships">
   <p:cSld>
     <p:bg>
       <p:bgPr>
@@ -8605,14 +8068,7 @@
         <p:cNvGrpSpPr/>
         <p:nvPr/>
       </p:nvGrpSpPr>
-      <p:grpSpPr>
-        <a:xfrm>
-          <a:off x="0" y="0"/>
-          <a:ext cx="0" cy="0"/>
-          <a:chOff x="0" y="0"/>
-          <a:chExt cx="0" cy="0"/>
-        </a:xfrm>
-      </p:grpSpPr>
+      <p:grpSpPr/>
       <p:sp>
         <p:nvSpPr>
           <p:cNvPr id="2" name="Rectangle 1"/>
@@ -8654,7 +8110,6 @@
           <a:lstStyle/>
           <a:p>
             <a:pPr algn="ctr"/>
-            <a:endParaRPr/>
           </a:p>
         </p:txBody>
       </p:sp>
@@ -8699,7 +8154,6 @@
           <a:lstStyle/>
           <a:p>
             <a:pPr algn="ctr"/>
-            <a:endParaRPr/>
           </a:p>
         </p:txBody>
       </p:sp>
@@ -8827,7 +8281,6 @@
                 </a:solidFill>
               </a:defRPr>
             </a:pPr>
-            <a:endParaRPr/>
           </a:p>
           <a:p>
             <a:pPr algn="l">
@@ -8991,7 +8444,6 @@
           <a:lstStyle/>
           <a:p>
             <a:pPr algn="ctr"/>
-            <a:endParaRPr/>
           </a:p>
         </p:txBody>
       </p:sp>
@@ -9174,7 +8626,6 @@
                 </a:solidFill>
               </a:defRPr>
             </a:pPr>
-            <a:endParaRPr/>
           </a:p>
           <a:p>
             <a:pPr algn="l">
@@ -9357,7 +8808,7 @@
 </file>
 
 <file path=ppt/slides/slide7.xml><?xml version="1.0" encoding="utf-8"?>
-<p:sld xmlns:a="http://schemas.openxmlformats.org/drawingml/2006/main" xmlns:r="http://schemas.openxmlformats.org/officeDocument/2006/relationships" xmlns:p="http://schemas.openxmlformats.org/presentationml/2006/main">
+<p:sld xmlns:a="http://schemas.openxmlformats.org/drawingml/2006/main" xmlns:p="http://schemas.openxmlformats.org/presentationml/2006/main" xmlns:r="http://schemas.openxmlformats.org/officeDocument/2006/relationships">
   <p:cSld>
     <p:bg>
       <p:bgPr>
@@ -9373,14 +8824,7 @@
         <p:cNvGrpSpPr/>
         <p:nvPr/>
       </p:nvGrpSpPr>
-      <p:grpSpPr>
-        <a:xfrm>
-          <a:off x="0" y="0"/>
-          <a:ext cx="0" cy="0"/>
-          <a:chOff x="0" y="0"/>
-          <a:chExt cx="0" cy="0"/>
-        </a:xfrm>
-      </p:grpSpPr>
+      <p:grpSpPr/>
       <p:sp>
         <p:nvSpPr>
           <p:cNvPr id="2" name="Rectangle 1"/>
@@ -9422,7 +8866,6 @@
           <a:lstStyle/>
           <a:p>
             <a:pPr algn="ctr"/>
-            <a:endParaRPr/>
           </a:p>
         </p:txBody>
       </p:sp>
@@ -9467,7 +8910,6 @@
           <a:lstStyle/>
           <a:p>
             <a:pPr algn="ctr"/>
-            <a:endParaRPr/>
           </a:p>
         </p:txBody>
       </p:sp>
@@ -9589,7 +9031,6 @@
                 </a:solidFill>
               </a:defRPr>
             </a:pPr>
-            <a:endParaRPr/>
           </a:p>
           <a:p>
             <a:pPr algn="l">
@@ -9668,7 +9109,6 @@
           <a:lstStyle/>
           <a:p>
             <a:pPr algn="ctr"/>
-            <a:endParaRPr/>
           </a:p>
         </p:txBody>
       </p:sp>
@@ -9751,7 +9191,7 @@
 </file>
 
 <file path=ppt/slides/slide8.xml><?xml version="1.0" encoding="utf-8"?>
-<p:sld xmlns:a="http://schemas.openxmlformats.org/drawingml/2006/main" xmlns:r="http://schemas.openxmlformats.org/officeDocument/2006/relationships" xmlns:p="http://schemas.openxmlformats.org/presentationml/2006/main">
+<p:sld xmlns:a="http://schemas.openxmlformats.org/drawingml/2006/main" xmlns:p="http://schemas.openxmlformats.org/presentationml/2006/main" xmlns:r="http://schemas.openxmlformats.org/officeDocument/2006/relationships">
   <p:cSld>
     <p:bg>
       <p:bgPr>
@@ -9767,14 +9207,7 @@
         <p:cNvGrpSpPr/>
         <p:nvPr/>
       </p:nvGrpSpPr>
-      <p:grpSpPr>
-        <a:xfrm>
-          <a:off x="0" y="0"/>
-          <a:ext cx="0" cy="0"/>
-          <a:chOff x="0" y="0"/>
-          <a:chExt cx="0" cy="0"/>
-        </a:xfrm>
-      </p:grpSpPr>
+      <p:grpSpPr/>
       <p:sp>
         <p:nvSpPr>
           <p:cNvPr id="2" name="Rectangle 1"/>
@@ -9816,7 +9249,6 @@
           <a:lstStyle/>
           <a:p>
             <a:pPr algn="ctr"/>
-            <a:endParaRPr/>
           </a:p>
         </p:txBody>
       </p:sp>
@@ -9861,7 +9293,6 @@
           <a:lstStyle/>
           <a:p>
             <a:pPr algn="ctr"/>
-            <a:endParaRPr/>
           </a:p>
         </p:txBody>
       </p:sp>
@@ -10059,7 +9490,6 @@
           <a:lstStyle/>
           <a:p>
             <a:pPr algn="ctr"/>
-            <a:endParaRPr/>
           </a:p>
         </p:txBody>
       </p:sp>
@@ -10142,7 +9572,7 @@
 </file>
 
 <file path=ppt/slides/slide9.xml><?xml version="1.0" encoding="utf-8"?>
-<p:sld xmlns:a="http://schemas.openxmlformats.org/drawingml/2006/main" xmlns:r="http://schemas.openxmlformats.org/officeDocument/2006/relationships" xmlns:p="http://schemas.openxmlformats.org/presentationml/2006/main">
+<p:sld xmlns:a="http://schemas.openxmlformats.org/drawingml/2006/main" xmlns:p="http://schemas.openxmlformats.org/presentationml/2006/main" xmlns:r="http://schemas.openxmlformats.org/officeDocument/2006/relationships">
   <p:cSld>
     <p:bg>
       <p:bgPr>
@@ -10158,14 +9588,7 @@
         <p:cNvGrpSpPr/>
         <p:nvPr/>
       </p:nvGrpSpPr>
-      <p:grpSpPr>
-        <a:xfrm>
-          <a:off x="0" y="0"/>
-          <a:ext cx="0" cy="0"/>
-          <a:chOff x="0" y="0"/>
-          <a:chExt cx="0" cy="0"/>
-        </a:xfrm>
-      </p:grpSpPr>
+      <p:grpSpPr/>
       <p:sp>
         <p:nvSpPr>
           <p:cNvPr id="2" name="Rectangle 1"/>
@@ -10207,7 +9630,6 @@
           <a:lstStyle/>
           <a:p>
             <a:pPr algn="ctr"/>
-            <a:endParaRPr/>
           </a:p>
         </p:txBody>
       </p:sp>
@@ -10252,7 +9674,6 @@
           <a:lstStyle/>
           <a:p>
             <a:pPr algn="ctr"/>
-            <a:endParaRPr/>
           </a:p>
         </p:txBody>
       </p:sp>
@@ -10485,7 +9906,6 @@
           <a:lstStyle/>
           <a:p>
             <a:pPr algn="ctr"/>
-            <a:endParaRPr/>
           </a:p>
         </p:txBody>
       </p:sp>

</xml_diff>

<commit_message>
redo fig gen to unify fig font size, translate some texts to Korean
</commit_message>
<xml_diff>
--- a/presentation/KSAS_Spring2026_Presentation.pptx
+++ b/presentation/KSAS_Spring2026_Presentation.pptx
@@ -3160,6 +3160,7 @@
                 <a:solidFill>
                   <a:srgbClr val="004AAD"/>
                 </a:solidFill>
+                <a:latin typeface="Nanum Square"/>
               </a:defRPr>
             </a:pPr>
             <a:r>
@@ -3198,6 +3199,7 @@
                 <a:solidFill>
                   <a:srgbClr val="000000"/>
                 </a:solidFill>
+                <a:latin typeface="Nanum Square"/>
               </a:defRPr>
             </a:pPr>
             <a:r>
@@ -3217,6 +3219,7 @@
                 <a:solidFill>
                   <a:srgbClr val="666666"/>
                 </a:solidFill>
+                <a:latin typeface="Nanum Square"/>
               </a:defRPr>
             </a:pPr>
             <a:r>
@@ -3232,6 +3235,7 @@
                 <a:solidFill>
                   <a:srgbClr val="999999"/>
                 </a:solidFill>
+                <a:latin typeface="Nanum Square"/>
               </a:defRPr>
             </a:pPr>
             <a:r>
@@ -3267,6 +3271,7 @@
                 <a:solidFill>
                   <a:srgbClr val="000000"/>
                 </a:solidFill>
+                <a:latin typeface="Nanum Square"/>
               </a:defRPr>
             </a:pPr>
             <a:r>
@@ -3282,6 +3287,7 @@
                 <a:solidFill>
                   <a:srgbClr val="666666"/>
                 </a:solidFill>
+                <a:latin typeface="Nanum Square"/>
               </a:defRPr>
             </a:pPr>
             <a:r>
@@ -3317,6 +3323,7 @@
                 <a:solidFill>
                   <a:srgbClr val="666666"/>
                 </a:solidFill>
+                <a:latin typeface="Nanum Square"/>
               </a:defRPr>
             </a:pPr>
             <a:r>
@@ -3466,6 +3473,7 @@
                 <a:solidFill>
                   <a:srgbClr val="000000"/>
                 </a:solidFill>
+                <a:latin typeface="Nanum Square"/>
               </a:defRPr>
             </a:pPr>
             <a:r>
@@ -3476,16 +3484,16 @@
       </p:sp>
       <p:sp>
         <p:nvSpPr>
-          <p:cNvPr id="5" name="Rectangle 4"/>
+          <p:cNvPr id="5" name="Rounded Rectangle 4"/>
           <p:cNvSpPr/>
           <p:nvPr/>
         </p:nvSpPr>
         <p:spPr>
           <a:xfrm>
             <a:off x="1463040" y="2971800"/>
-            <a:ext cx="7223760" cy="2468880"/>
-          </a:xfrm>
-          <a:prstGeom prst="rect">
+            <a:ext cx="7223760" cy="2377440"/>
+          </a:xfrm>
+          <a:prstGeom prst="roundRect">
             <a:avLst/>
           </a:prstGeom>
           <a:solidFill>
@@ -3545,6 +3553,7 @@
                 <a:solidFill>
                   <a:srgbClr val="C0392B"/>
                 </a:solidFill>
+                <a:latin typeface="Nanum Square"/>
               </a:defRPr>
             </a:pPr>
             <a:r>
@@ -3580,6 +3589,7 @@
                 <a:solidFill>
                   <a:srgbClr val="999999"/>
                 </a:solidFill>
+                <a:latin typeface="Nanum Square"/>
               </a:defRPr>
             </a:pPr>
             <a:r>
@@ -3615,6 +3625,7 @@
                 <a:solidFill>
                   <a:srgbClr val="2D2D2D"/>
                 </a:solidFill>
+                <a:latin typeface="Nanum Square"/>
               </a:defRPr>
             </a:pPr>
             <a:r>
@@ -3629,16 +3640,16 @@
       </p:sp>
       <p:sp>
         <p:nvSpPr>
-          <p:cNvPr id="9" name="Rectangle 8"/>
+          <p:cNvPr id="9" name="Rounded Rectangle 8"/>
           <p:cNvSpPr/>
           <p:nvPr/>
         </p:nvSpPr>
         <p:spPr>
           <a:xfrm>
             <a:off x="9235440" y="2971800"/>
-            <a:ext cx="7223760" cy="2468880"/>
-          </a:xfrm>
-          <a:prstGeom prst="rect">
+            <a:ext cx="7223760" cy="2377440"/>
+          </a:xfrm>
+          <a:prstGeom prst="roundRect">
             <a:avLst/>
           </a:prstGeom>
           <a:solidFill>
@@ -3698,6 +3709,7 @@
                 <a:solidFill>
                   <a:srgbClr val="C0392B"/>
                 </a:solidFill>
+                <a:latin typeface="Nanum Square"/>
               </a:defRPr>
             </a:pPr>
             <a:r>
@@ -3733,6 +3745,7 @@
                 <a:solidFill>
                   <a:srgbClr val="999999"/>
                 </a:solidFill>
+                <a:latin typeface="Nanum Square"/>
               </a:defRPr>
             </a:pPr>
             <a:r>
@@ -3768,6 +3781,7 @@
                 <a:solidFill>
                   <a:srgbClr val="2D2D2D"/>
                 </a:solidFill>
+                <a:latin typeface="Nanum Square"/>
               </a:defRPr>
             </a:pPr>
             <a:r>
@@ -3782,16 +3796,16 @@
       </p:sp>
       <p:sp>
         <p:nvSpPr>
-          <p:cNvPr id="13" name="Rectangle 12"/>
+          <p:cNvPr id="13" name="Rounded Rectangle 12"/>
           <p:cNvSpPr/>
           <p:nvPr/>
         </p:nvSpPr>
         <p:spPr>
           <a:xfrm>
             <a:off x="1463040" y="5715000"/>
-            <a:ext cx="7223760" cy="2468880"/>
-          </a:xfrm>
-          <a:prstGeom prst="rect">
+            <a:ext cx="7223760" cy="2377440"/>
+          </a:xfrm>
+          <a:prstGeom prst="roundRect">
             <a:avLst/>
           </a:prstGeom>
           <a:solidFill>
@@ -3851,6 +3865,7 @@
                 <a:solidFill>
                   <a:srgbClr val="C0392B"/>
                 </a:solidFill>
+                <a:latin typeface="Nanum Square"/>
               </a:defRPr>
             </a:pPr>
             <a:r>
@@ -3886,6 +3901,7 @@
                 <a:solidFill>
                   <a:srgbClr val="999999"/>
                 </a:solidFill>
+                <a:latin typeface="Nanum Square"/>
               </a:defRPr>
             </a:pPr>
             <a:r>
@@ -3921,6 +3937,7 @@
                 <a:solidFill>
                   <a:srgbClr val="2D2D2D"/>
                 </a:solidFill>
+                <a:latin typeface="Nanum Square"/>
               </a:defRPr>
             </a:pPr>
             <a:r>
@@ -3935,16 +3952,16 @@
       </p:sp>
       <p:sp>
         <p:nvSpPr>
-          <p:cNvPr id="17" name="Rectangle 16"/>
+          <p:cNvPr id="17" name="Rounded Rectangle 16"/>
           <p:cNvSpPr/>
           <p:nvPr/>
         </p:nvSpPr>
         <p:spPr>
           <a:xfrm>
             <a:off x="9235440" y="5715000"/>
-            <a:ext cx="7223760" cy="2468880"/>
-          </a:xfrm>
-          <a:prstGeom prst="rect">
+            <a:ext cx="7223760" cy="2377440"/>
+          </a:xfrm>
+          <a:prstGeom prst="roundRect">
             <a:avLst/>
           </a:prstGeom>
           <a:solidFill>
@@ -4004,6 +4021,7 @@
                 <a:solidFill>
                   <a:srgbClr val="C0392B"/>
                 </a:solidFill>
+                <a:latin typeface="Nanum Square"/>
               </a:defRPr>
             </a:pPr>
             <a:r>
@@ -4039,6 +4057,7 @@
                 <a:solidFill>
                   <a:srgbClr val="999999"/>
                 </a:solidFill>
+                <a:latin typeface="Nanum Square"/>
               </a:defRPr>
             </a:pPr>
             <a:r>
@@ -4074,6 +4093,7 @@
                 <a:solidFill>
                   <a:srgbClr val="2D2D2D"/>
                 </a:solidFill>
+                <a:latin typeface="Nanum Square"/>
               </a:defRPr>
             </a:pPr>
             <a:r>
@@ -4088,16 +4108,16 @@
       </p:sp>
       <p:sp>
         <p:nvSpPr>
-          <p:cNvPr id="21" name="Rectangle 20"/>
+          <p:cNvPr id="21" name="Rounded Rectangle 20"/>
           <p:cNvSpPr/>
           <p:nvPr/>
         </p:nvSpPr>
         <p:spPr>
           <a:xfrm>
-            <a:off x="2441448" y="8595360"/>
-            <a:ext cx="13405104" cy="914400"/>
-          </a:xfrm>
-          <a:prstGeom prst="rect">
+            <a:off x="2441448" y="8046720"/>
+            <a:ext cx="13405104" cy="1097280"/>
+          </a:xfrm>
+          <a:prstGeom prst="roundRect">
             <a:avLst/>
           </a:prstGeom>
           <a:solidFill>
@@ -4138,8 +4158,8 @@
         </p:nvSpPr>
         <p:spPr>
           <a:xfrm>
-            <a:off x="2807208" y="8961120"/>
-            <a:ext cx="12673584" cy="640080"/>
+            <a:off x="2807208" y="8412480"/>
+            <a:ext cx="12673584" cy="822960"/>
           </a:xfrm>
           <a:prstGeom prst="rect">
             <a:avLst/>
@@ -4152,11 +4172,12 @@
           </a:bodyPr>
           <a:lstStyle/>
           <a:p>
-            <a:pPr algn="l">
+            <a:pPr algn="ctr">
               <a:defRPr sz="2000" b="1">
                 <a:solidFill>
                   <a:srgbClr val="000000"/>
                 </a:solidFill>
+                <a:latin typeface="Nanum Square"/>
               </a:defRPr>
             </a:pPr>
             <a:r>
@@ -4192,6 +4213,7 @@
                 <a:solidFill>
                   <a:srgbClr val="666666"/>
                 </a:solidFill>
+                <a:latin typeface="Nanum Square"/>
               </a:defRPr>
             </a:pPr>
             <a:r>
@@ -4341,6 +4363,7 @@
                 <a:solidFill>
                   <a:srgbClr val="000000"/>
                 </a:solidFill>
+                <a:latin typeface="Nanum Square"/>
               </a:defRPr>
             </a:pPr>
             <a:r>
@@ -4376,6 +4399,7 @@
                 <a:solidFill>
                   <a:srgbClr val="004AAD"/>
                 </a:solidFill>
+                <a:latin typeface="Nanum Square"/>
               </a:defRPr>
             </a:pPr>
             <a:r>
@@ -4391,6 +4415,7 @@
                 <a:solidFill>
                   <a:srgbClr val="999999"/>
                 </a:solidFill>
+                <a:latin typeface="Nanum Square"/>
               </a:defRPr>
             </a:pPr>
             <a:r>
@@ -4406,6 +4431,7 @@
                 <a:solidFill>
                   <a:srgbClr val="2D2D2D"/>
                 </a:solidFill>
+                <a:latin typeface="Nanum Square"/>
               </a:defRPr>
             </a:pPr>
             <a:r>
@@ -4425,6 +4451,7 @@
                 <a:solidFill>
                   <a:srgbClr val="999999"/>
                 </a:solidFill>
+                <a:latin typeface="Nanum Square"/>
               </a:defRPr>
             </a:pPr>
             <a:r>
@@ -4440,6 +4467,7 @@
                 <a:solidFill>
                   <a:srgbClr val="2D2D2D"/>
                 </a:solidFill>
+                <a:latin typeface="Nanum Square"/>
               </a:defRPr>
             </a:pPr>
             <a:r>
@@ -4459,6 +4487,7 @@
                 <a:solidFill>
                   <a:srgbClr val="999999"/>
                 </a:solidFill>
+                <a:latin typeface="Nanum Square"/>
               </a:defRPr>
             </a:pPr>
             <a:r>
@@ -4474,6 +4503,7 @@
                 <a:solidFill>
                   <a:srgbClr val="2D2D2D"/>
                 </a:solidFill>
+                <a:latin typeface="Nanum Square"/>
               </a:defRPr>
             </a:pPr>
             <a:r>
@@ -4493,6 +4523,7 @@
                 <a:solidFill>
                   <a:srgbClr val="999999"/>
                 </a:solidFill>
+                <a:latin typeface="Nanum Square"/>
               </a:defRPr>
             </a:pPr>
             <a:r>
@@ -4571,6 +4602,7 @@
                 <a:solidFill>
                   <a:srgbClr val="004AAD"/>
                 </a:solidFill>
+                <a:latin typeface="Nanum Square"/>
               </a:defRPr>
             </a:pPr>
             <a:r>
@@ -4586,6 +4618,7 @@
                 <a:solidFill>
                   <a:srgbClr val="999999"/>
                 </a:solidFill>
+                <a:latin typeface="Nanum Square"/>
               </a:defRPr>
             </a:pPr>
             <a:r>
@@ -4601,6 +4634,7 @@
                 <a:solidFill>
                   <a:srgbClr val="2D2D2D"/>
                 </a:solidFill>
+                <a:latin typeface="Nanum Square"/>
               </a:defRPr>
             </a:pPr>
             <a:r>
@@ -4616,6 +4650,7 @@
                 <a:solidFill>
                   <a:srgbClr val="999999"/>
                 </a:solidFill>
+                <a:latin typeface="Nanum Square"/>
               </a:defRPr>
             </a:pPr>
             <a:r>
@@ -4631,6 +4666,7 @@
                 <a:solidFill>
                   <a:srgbClr val="2D2D2D"/>
                 </a:solidFill>
+                <a:latin typeface="Nanum Square"/>
               </a:defRPr>
             </a:pPr>
             <a:r>
@@ -4650,6 +4686,7 @@
                 <a:solidFill>
                   <a:srgbClr val="999999"/>
                 </a:solidFill>
+                <a:latin typeface="Nanum Square"/>
               </a:defRPr>
             </a:pPr>
             <a:r>
@@ -4665,6 +4702,7 @@
                 <a:solidFill>
                   <a:srgbClr val="2D2D2D"/>
                 </a:solidFill>
+                <a:latin typeface="Nanum Square"/>
               </a:defRPr>
             </a:pPr>
             <a:r>
@@ -4684,6 +4722,7 @@
                 <a:solidFill>
                   <a:srgbClr val="999999"/>
                 </a:solidFill>
+                <a:latin typeface="Nanum Square"/>
               </a:defRPr>
             </a:pPr>
             <a:r>
@@ -4694,16 +4733,16 @@
       </p:sp>
       <p:sp>
         <p:nvSpPr>
-          <p:cNvPr id="8" name="Rectangle 7"/>
+          <p:cNvPr id="8" name="Rounded Rectangle 7"/>
           <p:cNvSpPr/>
           <p:nvPr/>
         </p:nvSpPr>
         <p:spPr>
           <a:xfrm>
             <a:off x="2441448" y="8046720"/>
-            <a:ext cx="13405104" cy="1463040"/>
-          </a:xfrm>
-          <a:prstGeom prst="rect">
+            <a:ext cx="13405104" cy="1097280"/>
+          </a:xfrm>
+          <a:prstGeom prst="roundRect">
             <a:avLst/>
           </a:prstGeom>
           <a:solidFill>
@@ -4745,7 +4784,7 @@
         <p:spPr>
           <a:xfrm>
             <a:off x="2807208" y="8412480"/>
-            <a:ext cx="12673584" cy="1188720"/>
+            <a:ext cx="12673584" cy="822960"/>
           </a:xfrm>
           <a:prstGeom prst="rect">
             <a:avLst/>
@@ -4758,11 +4797,12 @@
           </a:bodyPr>
           <a:lstStyle/>
           <a:p>
-            <a:pPr algn="l">
+            <a:pPr algn="ctr">
               <a:defRPr sz="2000" b="1">
                 <a:solidFill>
                   <a:srgbClr val="000000"/>
                 </a:solidFill>
+                <a:latin typeface="Nanum Square"/>
               </a:defRPr>
             </a:pPr>
             <a:r>
@@ -4778,6 +4818,7 @@
                 <a:solidFill>
                   <a:srgbClr val="004AAD"/>
                 </a:solidFill>
+                <a:latin typeface="Nanum Square"/>
               </a:defRPr>
             </a:pPr>
             <a:r>
@@ -4813,6 +4854,7 @@
                 <a:solidFill>
                   <a:srgbClr val="666666"/>
                 </a:solidFill>
+                <a:latin typeface="Nanum Square"/>
               </a:defRPr>
             </a:pPr>
             <a:r>
@@ -4962,6 +5004,7 @@
                 <a:solidFill>
                   <a:srgbClr val="000000"/>
                 </a:solidFill>
+                <a:latin typeface="Nanum Square"/>
               </a:defRPr>
             </a:pPr>
             <a:r>
@@ -4997,6 +5040,7 @@
                 <a:solidFill>
                   <a:srgbClr val="004AAD"/>
                 </a:solidFill>
+                <a:latin typeface="Nanum Square"/>
               </a:defRPr>
             </a:pPr>
             <a:r>
@@ -5059,6 +5103,7 @@
                 <a:solidFill>
                   <a:srgbClr val="2D2D2D"/>
                 </a:solidFill>
+                <a:latin typeface="Nanum Square"/>
               </a:defRPr>
             </a:pPr>
             <a:r>
@@ -5098,6 +5143,7 @@
                 <a:solidFill>
                   <a:srgbClr val="004AAD"/>
                 </a:solidFill>
+                <a:latin typeface="Nanum Square"/>
               </a:defRPr>
             </a:pPr>
             <a:r>
@@ -5113,6 +5159,7 @@
                 <a:solidFill>
                   <a:srgbClr val="2D2D2D"/>
                 </a:solidFill>
+                <a:latin typeface="Nanum Square"/>
               </a:defRPr>
             </a:pPr>
             <a:r>
@@ -5152,6 +5199,7 @@
                 <a:solidFill>
                   <a:srgbClr val="004AAD"/>
                 </a:solidFill>
+                <a:latin typeface="Nanum Square"/>
               </a:defRPr>
             </a:pPr>
             <a:r>
@@ -5167,6 +5215,7 @@
                 <a:solidFill>
                   <a:srgbClr val="2D2D2D"/>
                 </a:solidFill>
+                <a:latin typeface="Nanum Square"/>
               </a:defRPr>
             </a:pPr>
             <a:r>
@@ -5206,6 +5255,7 @@
                 <a:solidFill>
                   <a:srgbClr val="004AAD"/>
                 </a:solidFill>
+                <a:latin typeface="Nanum Square"/>
               </a:defRPr>
             </a:pPr>
             <a:r>
@@ -5221,6 +5271,7 @@
                 <a:solidFill>
                   <a:srgbClr val="2D2D2D"/>
                 </a:solidFill>
+                <a:latin typeface="Nanum Square"/>
               </a:defRPr>
             </a:pPr>
             <a:r>
@@ -5260,6 +5311,7 @@
                 <a:solidFill>
                   <a:srgbClr val="004AAD"/>
                 </a:solidFill>
+                <a:latin typeface="Nanum Square"/>
               </a:defRPr>
             </a:pPr>
             <a:r>
@@ -5275,6 +5327,7 @@
                 <a:solidFill>
                   <a:srgbClr val="2D2D2D"/>
                 </a:solidFill>
+                <a:latin typeface="Nanum Square"/>
               </a:defRPr>
             </a:pPr>
             <a:r>
@@ -5314,6 +5367,7 @@
                 <a:solidFill>
                   <a:srgbClr val="004AAD"/>
                 </a:solidFill>
+                <a:latin typeface="Nanum Square"/>
               </a:defRPr>
             </a:pPr>
             <a:r>
@@ -5329,6 +5383,7 @@
                 <a:solidFill>
                   <a:srgbClr val="2D2D2D"/>
                 </a:solidFill>
+                <a:latin typeface="Nanum Square"/>
               </a:defRPr>
             </a:pPr>
             <a:r>
@@ -5368,6 +5423,7 @@
                 <a:solidFill>
                   <a:srgbClr val="004AAD"/>
                 </a:solidFill>
+                <a:latin typeface="Nanum Square"/>
               </a:defRPr>
             </a:pPr>
             <a:r>
@@ -5383,6 +5439,7 @@
                 <a:solidFill>
                   <a:srgbClr val="2D2D2D"/>
                 </a:solidFill>
+                <a:latin typeface="Nanum Square"/>
               </a:defRPr>
             </a:pPr>
             <a:r>
@@ -5422,6 +5479,7 @@
                 <a:solidFill>
                   <a:srgbClr val="004AAD"/>
                 </a:solidFill>
+                <a:latin typeface="Nanum Square"/>
               </a:defRPr>
             </a:pPr>
             <a:r>
@@ -5437,6 +5495,7 @@
                 <a:solidFill>
                   <a:srgbClr val="2D2D2D"/>
                 </a:solidFill>
+                <a:latin typeface="Nanum Square"/>
               </a:defRPr>
             </a:pPr>
             <a:r>
@@ -5476,6 +5535,7 @@
                 <a:solidFill>
                   <a:srgbClr val="666666"/>
                 </a:solidFill>
+                <a:latin typeface="Nanum Square"/>
               </a:defRPr>
             </a:pPr>
             <a:r>
@@ -5625,6 +5685,7 @@
                 <a:solidFill>
                   <a:srgbClr val="000000"/>
                 </a:solidFill>
+                <a:latin typeface="Nanum Square"/>
               </a:defRPr>
             </a:pPr>
             <a:r>
@@ -5654,7 +5715,13 @@
             <a:spAutoFit/>
           </a:bodyPr>
           <a:lstStyle/>
-          <a:p/>
+          <a:p>
+            <a:pPr>
+              <a:defRPr>
+                <a:latin typeface="Nanum Square"/>
+              </a:defRPr>
+            </a:pPr>
+          </a:p>
         </p:txBody>
       </p:sp>
       <p:sp>
@@ -5684,6 +5751,7 @@
                 <a:solidFill>
                   <a:srgbClr val="004AAD"/>
                 </a:solidFill>
+                <a:latin typeface="Nanum Square"/>
               </a:defRPr>
             </a:pPr>
             <a:r>
@@ -5699,6 +5767,7 @@
                 <a:solidFill>
                   <a:srgbClr val="2D2D2D"/>
                 </a:solidFill>
+                <a:latin typeface="Nanum Square"/>
               </a:defRPr>
             </a:pPr>
             <a:r>
@@ -5714,6 +5783,7 @@
                 <a:solidFill>
                   <a:srgbClr val="999999"/>
                 </a:solidFill>
+                <a:latin typeface="Nanum Square"/>
               </a:defRPr>
             </a:pPr>
             <a:r>
@@ -5729,6 +5799,7 @@
                 <a:solidFill>
                   <a:srgbClr val="2D2D2D"/>
                 </a:solidFill>
+                <a:latin typeface="Nanum Square"/>
               </a:defRPr>
             </a:pPr>
             <a:r>
@@ -5744,6 +5815,7 @@
                 <a:solidFill>
                   <a:srgbClr val="999999"/>
                 </a:solidFill>
+                <a:latin typeface="Nanum Square"/>
               </a:defRPr>
             </a:pPr>
             <a:r>
@@ -5759,6 +5831,7 @@
                 <a:solidFill>
                   <a:srgbClr val="2D2D2D"/>
                 </a:solidFill>
+                <a:latin typeface="Nanum Square"/>
               </a:defRPr>
             </a:pPr>
             <a:r>
@@ -5774,6 +5847,7 @@
                 <a:solidFill>
                   <a:srgbClr val="999999"/>
                 </a:solidFill>
+                <a:latin typeface="Nanum Square"/>
               </a:defRPr>
             </a:pPr>
             <a:r>
@@ -5789,6 +5863,7 @@
                 <a:solidFill>
                   <a:srgbClr val="2D2D2D"/>
                 </a:solidFill>
+                <a:latin typeface="Nanum Square"/>
               </a:defRPr>
             </a:pPr>
             <a:r>
@@ -5804,6 +5879,7 @@
                 <a:solidFill>
                   <a:srgbClr val="999999"/>
                 </a:solidFill>
+                <a:latin typeface="Nanum Square"/>
               </a:defRPr>
             </a:pPr>
             <a:r>
@@ -5839,6 +5915,7 @@
                 <a:solidFill>
                   <a:srgbClr val="004AAD"/>
                 </a:solidFill>
+                <a:latin typeface="Nanum Square"/>
               </a:defRPr>
             </a:pPr>
             <a:r>
@@ -5854,6 +5931,7 @@
                 <a:solidFill>
                   <a:srgbClr val="2D2D2D"/>
                 </a:solidFill>
+                <a:latin typeface="Nanum Square"/>
               </a:defRPr>
             </a:pPr>
             <a:r>
@@ -5869,6 +5947,7 @@
                 <a:solidFill>
                   <a:srgbClr val="999999"/>
                 </a:solidFill>
+                <a:latin typeface="Nanum Square"/>
               </a:defRPr>
             </a:pPr>
             <a:r>
@@ -5884,6 +5963,7 @@
                 <a:solidFill>
                   <a:srgbClr val="2D2D2D"/>
                 </a:solidFill>
+                <a:latin typeface="Nanum Square"/>
               </a:defRPr>
             </a:pPr>
             <a:r>
@@ -5899,6 +5979,7 @@
                 <a:solidFill>
                   <a:srgbClr val="999999"/>
                 </a:solidFill>
+                <a:latin typeface="Nanum Square"/>
               </a:defRPr>
             </a:pPr>
             <a:r>
@@ -5914,6 +5995,7 @@
                 <a:solidFill>
                   <a:srgbClr val="2D2D2D"/>
                 </a:solidFill>
+                <a:latin typeface="Nanum Square"/>
               </a:defRPr>
             </a:pPr>
             <a:r>
@@ -5929,6 +6011,7 @@
                 <a:solidFill>
                   <a:srgbClr val="999999"/>
                 </a:solidFill>
+                <a:latin typeface="Nanum Square"/>
               </a:defRPr>
             </a:pPr>
             <a:r>
@@ -5944,6 +6027,7 @@
                 <a:solidFill>
                   <a:srgbClr val="2D2D2D"/>
                 </a:solidFill>
+                <a:latin typeface="Nanum Square"/>
               </a:defRPr>
             </a:pPr>
             <a:r>
@@ -5959,6 +6043,7 @@
                 <a:solidFill>
                   <a:srgbClr val="999999"/>
                 </a:solidFill>
+                <a:latin typeface="Nanum Square"/>
               </a:defRPr>
             </a:pPr>
             <a:r>
@@ -6012,7 +6097,7 @@
       </p:sp>
       <p:sp>
         <p:nvSpPr>
-          <p:cNvPr id="9" name="Rectangle 8"/>
+          <p:cNvPr id="9" name="Rounded Rectangle 8"/>
           <p:cNvSpPr/>
           <p:nvPr/>
         </p:nvSpPr>
@@ -6021,7 +6106,7 @@
             <a:off x="2441448" y="8046720"/>
             <a:ext cx="13405104" cy="1097280"/>
           </a:xfrm>
-          <a:prstGeom prst="rect">
+          <a:prstGeom prst="roundRect">
             <a:avLst/>
           </a:prstGeom>
           <a:solidFill>
@@ -6076,15 +6161,16 @@
           </a:bodyPr>
           <a:lstStyle/>
           <a:p>
-            <a:pPr algn="l">
+            <a:pPr algn="ctr">
               <a:defRPr sz="2000" b="1">
                 <a:solidFill>
                   <a:srgbClr val="000000"/>
                 </a:solidFill>
-              </a:defRPr>
-            </a:pPr>
-            <a:r>
-              <a:t>Can a physically closed loop remain stable, repeatable, and quantitatively explainable?</a:t>
+                <a:latin typeface="Nanum Square"/>
+              </a:defRPr>
+            </a:pPr>
+            <a:r>
+              <a:t>물리적 피드백 포함 HILS 구조의 안정성, 반복성, 정량적 설명 가능성 제시</a:t>
             </a:r>
           </a:p>
         </p:txBody>
@@ -6116,6 +6202,7 @@
                 <a:solidFill>
                   <a:srgbClr val="666666"/>
                 </a:solidFill>
+                <a:latin typeface="Nanum Square"/>
               </a:defRPr>
             </a:pPr>
             <a:r>
@@ -6265,6 +6352,7 @@
                 <a:solidFill>
                   <a:srgbClr val="000000"/>
                 </a:solidFill>
+                <a:latin typeface="Nanum Square"/>
               </a:defRPr>
             </a:pPr>
             <a:r>
@@ -6296,29 +6384,15 @@
           <a:lstStyle/>
           <a:p>
             <a:pPr algn="ctr">
-              <a:defRPr sz="2200">
+              <a:defRPr sz="2200" b="1">
                 <a:solidFill>
                   <a:srgbClr val="2D2D2D"/>
                 </a:solidFill>
-              </a:defRPr>
-            </a:pPr>
-            <a:r>
-              <a:t>Closed-loop feedback uses attitude estimated from real IMU motion, not only simulated sensor values.</a:t>
-            </a:r>
-          </a:p>
-          <a:p>
-            <a:pPr algn="ctr">
-              <a:spcBef>
-                <a:spcPts val="600"/>
-              </a:spcBef>
-              <a:defRPr sz="1600" b="0">
-                <a:solidFill>
-                  <a:srgbClr val="999999"/>
-                </a:solidFill>
-              </a:defRPr>
-            </a:pPr>
-            <a:r>
-              <a:t>폐루프 피드백이 실제 IMU 운동으로부터 추정된 자세를 사용</a:t>
+                <a:latin typeface="Nanum Square"/>
+              </a:defRPr>
+            </a:pPr>
+            <a:r>
+              <a:t>시뮬레이션 센서 값뿐만 아니라 실제 IMU 모션 기반 자세 추정치를 폐루프 피드백 입력으로 활용</a:t>
             </a:r>
           </a:p>
         </p:txBody>
@@ -6331,7 +6405,7 @@
         </p:nvSpPr>
         <p:spPr>
           <a:xfrm>
-            <a:off x="1371600" y="4389120"/>
+            <a:off x="1828800" y="4389120"/>
             <a:ext cx="4572000" cy="457200"/>
           </a:xfrm>
           <a:prstGeom prst="rect">
@@ -6350,6 +6424,7 @@
                 <a:solidFill>
                   <a:srgbClr val="004AAD"/>
                 </a:solidFill>
+                <a:latin typeface="Nanum Square"/>
               </a:defRPr>
             </a:pPr>
             <a:r>
@@ -6366,7 +6441,7 @@
         </p:nvSpPr>
         <p:spPr>
           <a:xfrm>
-            <a:off x="1371600" y="4937760"/>
+            <a:off x="1828800" y="4937760"/>
             <a:ext cx="4572000" cy="457200"/>
           </a:xfrm>
           <a:prstGeom prst="rect">
@@ -6385,6 +6460,7 @@
                 <a:solidFill>
                   <a:srgbClr val="2D2D2D"/>
                 </a:solidFill>
+                <a:latin typeface="Nanum Square"/>
               </a:defRPr>
             </a:pPr>
             <a:r>
@@ -6401,7 +6477,7 @@
         </p:nvSpPr>
         <p:spPr>
           <a:xfrm>
-            <a:off x="1371600" y="5486400"/>
+            <a:off x="1828800" y="5394960"/>
             <a:ext cx="4572000" cy="1645920"/>
           </a:xfrm>
           <a:prstGeom prst="rect">
@@ -6420,6 +6496,7 @@
                 <a:solidFill>
                   <a:srgbClr val="2D2D2D"/>
                 </a:solidFill>
+                <a:latin typeface="Nanum Square"/>
               </a:defRPr>
             </a:pPr>
             <a:r>
@@ -6439,6 +6516,7 @@
                 <a:solidFill>
                   <a:srgbClr val="999999"/>
                 </a:solidFill>
+                <a:latin typeface="Nanum Square"/>
               </a:defRPr>
             </a:pPr>
             <a:r>
@@ -6455,7 +6533,7 @@
         </p:nvSpPr>
         <p:spPr>
           <a:xfrm>
-            <a:off x="6400800" y="4389120"/>
+            <a:off x="6858000" y="4389120"/>
             <a:ext cx="4572000" cy="457200"/>
           </a:xfrm>
           <a:prstGeom prst="rect">
@@ -6474,6 +6552,7 @@
                 <a:solidFill>
                   <a:srgbClr val="004AAD"/>
                 </a:solidFill>
+                <a:latin typeface="Nanum Square"/>
               </a:defRPr>
             </a:pPr>
             <a:r>
@@ -6490,7 +6569,7 @@
         </p:nvSpPr>
         <p:spPr>
           <a:xfrm>
-            <a:off x="6400800" y="4937760"/>
+            <a:off x="6858000" y="4937760"/>
             <a:ext cx="4572000" cy="457200"/>
           </a:xfrm>
           <a:prstGeom prst="rect">
@@ -6509,6 +6588,7 @@
                 <a:solidFill>
                   <a:srgbClr val="2D2D2D"/>
                 </a:solidFill>
+                <a:latin typeface="Nanum Square"/>
               </a:defRPr>
             </a:pPr>
             <a:r>
@@ -6525,7 +6605,7 @@
         </p:nvSpPr>
         <p:spPr>
           <a:xfrm>
-            <a:off x="6400800" y="5486400"/>
+            <a:off x="6858000" y="5394960"/>
             <a:ext cx="4572000" cy="1645920"/>
           </a:xfrm>
           <a:prstGeom prst="rect">
@@ -6544,6 +6624,7 @@
                 <a:solidFill>
                   <a:srgbClr val="2D2D2D"/>
                 </a:solidFill>
+                <a:latin typeface="Nanum Square"/>
               </a:defRPr>
             </a:pPr>
             <a:r>
@@ -6563,6 +6644,7 @@
                 <a:solidFill>
                   <a:srgbClr val="999999"/>
                 </a:solidFill>
+                <a:latin typeface="Nanum Square"/>
               </a:defRPr>
             </a:pPr>
             <a:r>
@@ -6579,7 +6661,7 @@
         </p:nvSpPr>
         <p:spPr>
           <a:xfrm>
-            <a:off x="11430000" y="4389120"/>
+            <a:off x="11887200" y="4389120"/>
             <a:ext cx="4572000" cy="457200"/>
           </a:xfrm>
           <a:prstGeom prst="rect">
@@ -6598,6 +6680,7 @@
                 <a:solidFill>
                   <a:srgbClr val="004AAD"/>
                 </a:solidFill>
+                <a:latin typeface="Nanum Square"/>
               </a:defRPr>
             </a:pPr>
             <a:r>
@@ -6614,7 +6697,7 @@
         </p:nvSpPr>
         <p:spPr>
           <a:xfrm>
-            <a:off x="11430000" y="4937760"/>
+            <a:off x="11887200" y="4937760"/>
             <a:ext cx="4572000" cy="457200"/>
           </a:xfrm>
           <a:prstGeom prst="rect">
@@ -6633,6 +6716,7 @@
                 <a:solidFill>
                   <a:srgbClr val="2D2D2D"/>
                 </a:solidFill>
+                <a:latin typeface="Nanum Square"/>
               </a:defRPr>
             </a:pPr>
             <a:r>
@@ -6649,7 +6733,7 @@
         </p:nvSpPr>
         <p:spPr>
           <a:xfrm>
-            <a:off x="11430000" y="5486400"/>
+            <a:off x="11887200" y="5394960"/>
             <a:ext cx="4572000" cy="1645920"/>
           </a:xfrm>
           <a:prstGeom prst="rect">
@@ -6668,6 +6752,7 @@
                 <a:solidFill>
                   <a:srgbClr val="2D2D2D"/>
                 </a:solidFill>
+                <a:latin typeface="Nanum Square"/>
               </a:defRPr>
             </a:pPr>
             <a:r>
@@ -6687,26 +6772,27 @@
                 <a:solidFill>
                   <a:srgbClr val="999999"/>
                 </a:solidFill>
-              </a:defRPr>
-            </a:pPr>
-            <a:r>
-              <a:t>측정 자세 → 호스트 제어 루프</a:t>
-            </a:r>
-          </a:p>
-        </p:txBody>
-      </p:sp>
-      <p:sp>
-        <p:nvSpPr>
-          <p:cNvPr id="15" name="Rectangle 14"/>
+                <a:latin typeface="Nanum Square"/>
+              </a:defRPr>
+            </a:pPr>
+            <a:r>
+              <a:t>측정된 자세 → 호스트 제어 루프</a:t>
+            </a:r>
+          </a:p>
+        </p:txBody>
+      </p:sp>
+      <p:sp>
+        <p:nvSpPr>
+          <p:cNvPr id="15" name="Rounded Rectangle 14"/>
           <p:cNvSpPr/>
           <p:nvPr/>
         </p:nvSpPr>
         <p:spPr>
           <a:xfrm>
-            <a:off x="2441448" y="7772400"/>
+            <a:off x="2441448" y="8046720"/>
             <a:ext cx="13405104" cy="1097280"/>
           </a:xfrm>
-          <a:prstGeom prst="rect">
+          <a:prstGeom prst="roundRect">
             <a:avLst/>
           </a:prstGeom>
           <a:solidFill>
@@ -6747,7 +6833,7 @@
         </p:nvSpPr>
         <p:spPr>
           <a:xfrm>
-            <a:off x="2807208" y="8138160"/>
+            <a:off x="2807208" y="8412480"/>
             <a:ext cx="12673584" cy="822960"/>
           </a:xfrm>
           <a:prstGeom prst="rect">
@@ -6761,15 +6847,16 @@
           </a:bodyPr>
           <a:lstStyle/>
           <a:p>
-            <a:pPr algn="l">
-              <a:defRPr sz="1800" b="1">
+            <a:pPr algn="ctr">
+              <a:defRPr sz="2000" b="1">
                 <a:solidFill>
                   <a:srgbClr val="000000"/>
                 </a:solidFill>
-              </a:defRPr>
-            </a:pPr>
-            <a:r>
-              <a:t>Complementary validation layer — not a full aerodynamic flight replacement.</a:t>
+                <a:latin typeface="Nanum Square"/>
+              </a:defRPr>
+            </a:pPr>
+            <a:r>
+              <a:t>⚠️ 연구 목적상 폐루프 성능 중심으로 설계되었으며, 전 영역 공력 효과는 포함하지 않습니다.</a:t>
             </a:r>
           </a:p>
         </p:txBody>
@@ -6801,6 +6888,7 @@
                 <a:solidFill>
                   <a:srgbClr val="666666"/>
                 </a:solidFill>
+                <a:latin typeface="Nanum Square"/>
               </a:defRPr>
             </a:pPr>
             <a:r>
@@ -6950,6 +7038,7 @@
                 <a:solidFill>
                   <a:srgbClr val="000000"/>
                 </a:solidFill>
+                <a:latin typeface="Nanum Square"/>
               </a:defRPr>
             </a:pPr>
             <a:r>
@@ -7005,6 +7094,7 @@
                 <a:solidFill>
                   <a:srgbClr val="666666"/>
                 </a:solidFill>
+                <a:latin typeface="Nanum Square"/>
               </a:defRPr>
             </a:pPr>
             <a:r>
@@ -7020,6 +7110,7 @@
                 <a:solidFill>
                   <a:srgbClr val="999999"/>
                 </a:solidFill>
+                <a:latin typeface="Nanum Square"/>
               </a:defRPr>
             </a:pPr>
             <a:r>
@@ -7075,6 +7166,7 @@
                 <a:solidFill>
                   <a:srgbClr val="666666"/>
                 </a:solidFill>
+                <a:latin typeface="Nanum Square"/>
               </a:defRPr>
             </a:pPr>
             <a:r>
@@ -7090,6 +7182,7 @@
                 <a:solidFill>
                   <a:srgbClr val="999999"/>
                 </a:solidFill>
+                <a:latin typeface="Nanum Square"/>
               </a:defRPr>
             </a:pPr>
             <a:r>
@@ -7100,7 +7193,7 @@
       </p:sp>
       <p:sp>
         <p:nvSpPr>
-          <p:cNvPr id="7" name="Rectangle 6"/>
+          <p:cNvPr id="7" name="Rounded Rectangle 6"/>
           <p:cNvSpPr/>
           <p:nvPr/>
         </p:nvSpPr>
@@ -7109,7 +7202,7 @@
             <a:off x="2441448" y="8046720"/>
             <a:ext cx="13405104" cy="1097280"/>
           </a:xfrm>
-          <a:prstGeom prst="rect">
+          <a:prstGeom prst="roundRect">
             <a:avLst/>
           </a:prstGeom>
           <a:solidFill>
@@ -7164,11 +7257,12 @@
           </a:bodyPr>
           <a:lstStyle/>
           <a:p>
-            <a:pPr algn="l">
+            <a:pPr algn="ctr">
               <a:defRPr sz="2000" b="1">
                 <a:solidFill>
                   <a:srgbClr val="000000"/>
                 </a:solidFill>
+                <a:latin typeface="Nanum Square"/>
               </a:defRPr>
             </a:pPr>
             <a:r>
@@ -7204,6 +7298,7 @@
                 <a:solidFill>
                   <a:srgbClr val="666666"/>
                 </a:solidFill>
+                <a:latin typeface="Nanum Square"/>
               </a:defRPr>
             </a:pPr>
             <a:r>
@@ -7353,6 +7448,7 @@
                 <a:solidFill>
                   <a:srgbClr val="000000"/>
                 </a:solidFill>
+                <a:latin typeface="Nanum Square"/>
               </a:defRPr>
             </a:pPr>
             <a:r>
@@ -7377,8 +7473,8 @@
         </p:blipFill>
         <p:spPr>
           <a:xfrm>
-            <a:off x="914400" y="3108960"/>
-            <a:ext cx="7985301" cy="5443200"/>
+            <a:off x="2468880" y="3108960"/>
+            <a:ext cx="6865668" cy="4680000"/>
           </a:xfrm>
           <a:prstGeom prst="rect">
             <a:avLst/>
@@ -7393,7 +7489,7 @@
         </p:nvSpPr>
         <p:spPr>
           <a:xfrm>
-            <a:off x="1487667" y="4021820"/>
+            <a:off x="3009933" y="3608302"/>
             <a:ext cx="502920" cy="502920"/>
           </a:xfrm>
           <a:prstGeom prst="ellipse">
@@ -7432,6 +7528,7 @@
                 <a:solidFill>
                   <a:srgbClr val="FFFFFF"/>
                 </a:solidFill>
+                <a:latin typeface="Nanum Square"/>
               </a:defRPr>
             </a:pPr>
             <a:r>
@@ -7448,7 +7545,7 @@
         </p:nvSpPr>
         <p:spPr>
           <a:xfrm>
-            <a:off x="1148073" y="5671275"/>
+            <a:off x="3009933" y="5172473"/>
             <a:ext cx="502920" cy="502920"/>
           </a:xfrm>
           <a:prstGeom prst="ellipse">
@@ -7487,6 +7584,7 @@
                 <a:solidFill>
                   <a:srgbClr val="FFFFFF"/>
                 </a:solidFill>
+                <a:latin typeface="Nanum Square"/>
               </a:defRPr>
             </a:pPr>
             <a:r>
@@ -7503,7 +7601,7 @@
         </p:nvSpPr>
         <p:spPr>
           <a:xfrm>
-            <a:off x="4058876" y="6981136"/>
+            <a:off x="5262339" y="6402954"/>
             <a:ext cx="502920" cy="502920"/>
           </a:xfrm>
           <a:prstGeom prst="ellipse">
@@ -7542,6 +7640,7 @@
                 <a:solidFill>
                   <a:srgbClr val="FFFFFF"/>
                 </a:solidFill>
+                <a:latin typeface="Nanum Square"/>
               </a:defRPr>
             </a:pPr>
             <a:r>
@@ -7558,7 +7657,7 @@
         </p:nvSpPr>
         <p:spPr>
           <a:xfrm>
-            <a:off x="7842919" y="5574248"/>
+            <a:off x="8140414" y="5172473"/>
             <a:ext cx="502920" cy="502920"/>
           </a:xfrm>
           <a:prstGeom prst="ellipse">
@@ -7597,6 +7696,7 @@
                 <a:solidFill>
                   <a:srgbClr val="FFFFFF"/>
                 </a:solidFill>
+                <a:latin typeface="Nanum Square"/>
               </a:defRPr>
             </a:pPr>
             <a:r>
@@ -7632,6 +7732,7 @@
                 <a:solidFill>
                   <a:srgbClr val="004AAD"/>
                 </a:solidFill>
+                <a:latin typeface="Nanum Square"/>
               </a:defRPr>
             </a:pPr>
             <a:r>
@@ -7648,7 +7749,7 @@
         </p:nvSpPr>
         <p:spPr>
           <a:xfrm>
-            <a:off x="11795760" y="3108960"/>
+            <a:off x="11795760" y="3144960"/>
             <a:ext cx="5486400" cy="1188720"/>
           </a:xfrm>
           <a:prstGeom prst="rect">
@@ -7666,10 +7767,11 @@
               <a:lnSpc>
                 <a:spcPts val="2400"/>
               </a:lnSpc>
-              <a:defRPr sz="1800">
+              <a:defRPr sz="2400">
                 <a:solidFill>
                   <a:srgbClr val="2D2D2D"/>
                 </a:solidFill>
+                <a:latin typeface="Nanum Square"/>
               </a:defRPr>
             </a:pPr>
             <a:r>
@@ -7678,21 +7780,6 @@
             <a:br/>
             <a:r>
               <a:t>to the Python host over UDP.</a:t>
-            </a:r>
-          </a:p>
-          <a:p>
-            <a:pPr algn="l">
-              <a:spcBef>
-                <a:spcPts val="400"/>
-              </a:spcBef>
-              <a:defRPr sz="1400" b="0">
-                <a:solidFill>
-                  <a:srgbClr val="999999"/>
-                </a:solidFill>
-              </a:defRPr>
-            </a:pPr>
-            <a:r>
-              <a:t>X-Plane → UDP → Python 호스트</a:t>
             </a:r>
           </a:p>
         </p:txBody>
@@ -7705,7 +7792,7 @@
         </p:nvSpPr>
         <p:spPr>
           <a:xfrm>
-            <a:off x="11155680" y="4663440"/>
+            <a:off x="11155680" y="4297680"/>
             <a:ext cx="548640" cy="457200"/>
           </a:xfrm>
           <a:prstGeom prst="rect">
@@ -7724,6 +7811,7 @@
                 <a:solidFill>
                   <a:srgbClr val="004AAD"/>
                 </a:solidFill>
+                <a:latin typeface="Nanum Square"/>
               </a:defRPr>
             </a:pPr>
             <a:r>
@@ -7740,7 +7828,7 @@
         </p:nvSpPr>
         <p:spPr>
           <a:xfrm>
-            <a:off x="11795760" y="4663440"/>
+            <a:off x="11795760" y="4333680"/>
             <a:ext cx="5486400" cy="1188720"/>
           </a:xfrm>
           <a:prstGeom prst="rect">
@@ -7758,10 +7846,11 @@
               <a:lnSpc>
                 <a:spcPts val="2400"/>
               </a:lnSpc>
-              <a:defRPr sz="1800">
+              <a:defRPr sz="2400">
                 <a:solidFill>
                   <a:srgbClr val="2D2D2D"/>
                 </a:solidFill>
+                <a:latin typeface="Nanum Square"/>
               </a:defRPr>
             </a:pPr>
             <a:r>
@@ -7770,21 +7859,6 @@
             <a:br/>
             <a:r>
               <a:t>commands for the Stewart platform.</a:t>
-            </a:r>
-          </a:p>
-          <a:p>
-            <a:pPr algn="l">
-              <a:spcBef>
-                <a:spcPts val="400"/>
-              </a:spcBef>
-              <a:defRPr sz="1400" b="0">
-                <a:solidFill>
-                  <a:srgbClr val="999999"/>
-                </a:solidFill>
-              </a:defRPr>
-            </a:pPr>
-            <a:r>
-              <a:t>호스트 → pose 명령 → 스튜어트 플랫폼</a:t>
             </a:r>
           </a:p>
         </p:txBody>
@@ -7797,7 +7871,7 @@
         </p:nvSpPr>
         <p:spPr>
           <a:xfrm>
-            <a:off x="11155680" y="6217920"/>
+            <a:off x="11155680" y="5486400"/>
             <a:ext cx="548640" cy="457200"/>
           </a:xfrm>
           <a:prstGeom prst="rect">
@@ -7816,6 +7890,7 @@
                 <a:solidFill>
                   <a:srgbClr val="004AAD"/>
                 </a:solidFill>
+                <a:latin typeface="Nanum Square"/>
               </a:defRPr>
             </a:pPr>
             <a:r>
@@ -7832,7 +7907,7 @@
         </p:nvSpPr>
         <p:spPr>
           <a:xfrm>
-            <a:off x="11795760" y="6217920"/>
+            <a:off x="11795760" y="5522400"/>
             <a:ext cx="5486400" cy="1188720"/>
           </a:xfrm>
           <a:prstGeom prst="rect">
@@ -7850,10 +7925,11 @@
               <a:lnSpc>
                 <a:spcPts val="2400"/>
               </a:lnSpc>
-              <a:defRPr sz="1800">
+              <a:defRPr sz="2400">
                 <a:solidFill>
                   <a:srgbClr val="2D2D2D"/>
                 </a:solidFill>
+                <a:latin typeface="Nanum Square"/>
               </a:defRPr>
             </a:pPr>
             <a:r>
@@ -7862,21 +7938,6 @@
             <a:br/>
             <a:r>
               <a:t>motion through its onboard IMU.</a:t>
-            </a:r>
-          </a:p>
-          <a:p>
-            <a:pPr algn="l">
-              <a:spcBef>
-                <a:spcPts val="400"/>
-              </a:spcBef>
-              <a:defRPr sz="1400" b="0">
-                <a:solidFill>
-                  <a:srgbClr val="999999"/>
-                </a:solidFill>
-              </a:defRPr>
-            </a:pPr>
-            <a:r>
-              <a:t>PX4 IMU가 플랫폼 모션을 물리적으로 감지</a:t>
             </a:r>
           </a:p>
         </p:txBody>
@@ -7889,7 +7950,7 @@
         </p:nvSpPr>
         <p:spPr>
           <a:xfrm>
-            <a:off x="11155680" y="7772400"/>
+            <a:off x="11155680" y="6675120"/>
             <a:ext cx="548640" cy="457200"/>
           </a:xfrm>
           <a:prstGeom prst="rect">
@@ -7908,6 +7969,7 @@
                 <a:solidFill>
                   <a:srgbClr val="004AAD"/>
                 </a:solidFill>
+                <a:latin typeface="Nanum Square"/>
               </a:defRPr>
             </a:pPr>
             <a:r>
@@ -7924,7 +7986,7 @@
         </p:nvSpPr>
         <p:spPr>
           <a:xfrm>
-            <a:off x="11795760" y="7772400"/>
+            <a:off x="11795760" y="6711120"/>
             <a:ext cx="5486400" cy="1188720"/>
           </a:xfrm>
           <a:prstGeom prst="rect">
@@ -7942,10 +8004,11 @@
               <a:lnSpc>
                 <a:spcPts val="2400"/>
               </a:lnSpc>
-              <a:defRPr sz="1800">
+              <a:defRPr sz="2400">
                 <a:solidFill>
                   <a:srgbClr val="2D2D2D"/>
                 </a:solidFill>
+                <a:latin typeface="Nanum Square"/>
               </a:defRPr>
             </a:pPr>
             <a:r>
@@ -7954,21 +8017,6 @@
             <a:br/>
             <a:r>
               <a:t>host injects control into X-Plane.</a:t>
-            </a:r>
-          </a:p>
-          <a:p>
-            <a:pPr algn="l">
-              <a:spcBef>
-                <a:spcPts val="400"/>
-              </a:spcBef>
-              <a:defRPr sz="1400" b="0">
-                <a:solidFill>
-                  <a:srgbClr val="999999"/>
-                </a:solidFill>
-              </a:defRPr>
-            </a:pPr>
-            <a:r>
-              <a:t>PX4 자세 → 호스트 → X-Plane 제어 주입</a:t>
             </a:r>
           </a:p>
         </p:txBody>
@@ -8000,6 +8048,7 @@
                 <a:solidFill>
                   <a:srgbClr val="004AAD"/>
                 </a:solidFill>
+                <a:latin typeface="Nanum Square"/>
               </a:defRPr>
             </a:pPr>
             <a:r>
@@ -8035,6 +8084,7 @@
                 <a:solidFill>
                   <a:srgbClr val="666666"/>
                 </a:solidFill>
+                <a:latin typeface="Nanum Square"/>
               </a:defRPr>
             </a:pPr>
             <a:r>
@@ -8184,6 +8234,7 @@
                 <a:solidFill>
                   <a:srgbClr val="000000"/>
                 </a:solidFill>
+                <a:latin typeface="Nanum Square"/>
               </a:defRPr>
             </a:pPr>
             <a:r>
@@ -8219,25 +8270,11 @@
                 <a:solidFill>
                   <a:srgbClr val="004AAD"/>
                 </a:solidFill>
+                <a:latin typeface="Nanum Square"/>
               </a:defRPr>
             </a:pPr>
             <a:r>
               <a:t>Baseline Scenario</a:t>
-            </a:r>
-          </a:p>
-          <a:p>
-            <a:pPr algn="l">
-              <a:spcBef>
-                <a:spcPts val="200"/>
-              </a:spcBef>
-              <a:defRPr sz="1600" b="0">
-                <a:solidFill>
-                  <a:srgbClr val="999999"/>
-                </a:solidFill>
-              </a:defRPr>
-            </a:pPr>
-            <a:r>
-              <a:t>기본 실험 시나리오</a:t>
             </a:r>
           </a:p>
           <a:p>
@@ -8249,6 +8286,7 @@
                 <a:solidFill>
                   <a:srgbClr val="2D2D2D"/>
                 </a:solidFill>
+                <a:latin typeface="Nanum Square"/>
               </a:defRPr>
             </a:pPr>
             <a:r>
@@ -8264,6 +8302,7 @@
                 <a:solidFill>
                   <a:srgbClr val="004AAD"/>
                 </a:solidFill>
+                <a:latin typeface="Nanum Square"/>
               </a:defRPr>
             </a:pPr>
             <a:r>
@@ -8279,127 +8318,140 @@
                 <a:solidFill>
                   <a:srgbClr val="2D2D2D"/>
                 </a:solidFill>
+                <a:latin typeface="Nanum Square"/>
               </a:defRPr>
             </a:pPr>
           </a:p>
           <a:p>
             <a:pPr algn="l">
               <a:spcBef>
-                <a:spcPts val="1000"/>
+                <a:spcPts val="800"/>
               </a:spcBef>
               <a:defRPr sz="1800" b="0">
                 <a:solidFill>
                   <a:srgbClr val="2D2D2D"/>
                 </a:solidFill>
-              </a:defRPr>
-            </a:pPr>
-            <a:r>
-              <a:t>•  Same initial condition each run</a:t>
+                <a:latin typeface="Nanum Square"/>
+              </a:defRPr>
+            </a:pPr>
+            <a:r>
+              <a:t>•  항상 동일 Honolulu (PHNL) 10nm 어프로치로 시작</a:t>
             </a:r>
           </a:p>
           <a:p>
             <a:pPr algn="l">
               <a:spcBef>
-                <a:spcPts val="200"/>
+                <a:spcPts val="648"/>
               </a:spcBef>
-              <a:defRPr sz="1400" b="0">
-                <a:solidFill>
-                  <a:srgbClr val="999999"/>
-                </a:solidFill>
-              </a:defRPr>
-            </a:pPr>
-            <a:r>
-              <a:t>    매 실험 동일 초기 조건</a:t>
-            </a:r>
+              <a:defRPr sz="800" b="0">
+                <a:solidFill>
+                  <a:srgbClr val="2D2D2D"/>
+                </a:solidFill>
+                <a:latin typeface="Nanum Square"/>
+              </a:defRPr>
+            </a:pPr>
           </a:p>
           <a:p>
             <a:pPr algn="l">
               <a:spcBef>
-                <a:spcPts val="1000"/>
+                <a:spcPts val="800"/>
               </a:spcBef>
               <a:defRPr sz="1800" b="0">
                 <a:solidFill>
                   <a:srgbClr val="2D2D2D"/>
                 </a:solidFill>
-              </a:defRPr>
-            </a:pPr>
-            <a:r>
-              <a:t>•  Repeated for statistics</a:t>
+                <a:latin typeface="Nanum Square"/>
+              </a:defRPr>
+            </a:pPr>
+            <a:r>
+              <a:t>•  스크립트로 적용된 유예 기간 동안 시스템 안정화 후 데이터 수집</a:t>
             </a:r>
           </a:p>
           <a:p>
             <a:pPr algn="l">
               <a:spcBef>
-                <a:spcPts val="200"/>
+                <a:spcPts val="648"/>
               </a:spcBef>
-              <a:defRPr sz="1400" b="0">
-                <a:solidFill>
-                  <a:srgbClr val="999999"/>
-                </a:solidFill>
-              </a:defRPr>
-            </a:pPr>
-            <a:r>
-              <a:t>    통계 확보를 위해 반복 수행</a:t>
-            </a:r>
+              <a:defRPr sz="800" b="0">
+                <a:solidFill>
+                  <a:srgbClr val="2D2D2D"/>
+                </a:solidFill>
+                <a:latin typeface="Nanum Square"/>
+              </a:defRPr>
+            </a:pPr>
           </a:p>
           <a:p>
             <a:pPr algn="l">
               <a:spcBef>
-                <a:spcPts val="1000"/>
+                <a:spcPts val="800"/>
               </a:spcBef>
               <a:defRPr sz="1800" b="0">
                 <a:solidFill>
                   <a:srgbClr val="2D2D2D"/>
                 </a:solidFill>
-              </a:defRPr>
-            </a:pPr>
-            <a:r>
-              <a:t>•  Neutral at z=+20 mm (max rotation)</a:t>
+                <a:latin typeface="Nanum Square"/>
+              </a:defRPr>
+            </a:pPr>
+            <a:r>
+              <a:t>•  Stewart 플랫폼의 포화 플래그(SAT) 감시; 작업 공간 내 유지</a:t>
             </a:r>
           </a:p>
           <a:p>
             <a:pPr algn="l">
               <a:spcBef>
-                <a:spcPts val="200"/>
+                <a:spcPts val="648"/>
               </a:spcBef>
-              <a:defRPr sz="1400" b="0">
-                <a:solidFill>
-                  <a:srgbClr val="999999"/>
-                </a:solidFill>
-              </a:defRPr>
-            </a:pPr>
-            <a:r>
-              <a:t>    z=+20 mm 기본 자세 (회전 범위 극대화)</a:t>
-            </a:r>
+              <a:defRPr sz="800" b="0">
+                <a:solidFill>
+                  <a:srgbClr val="2D2D2D"/>
+                </a:solidFill>
+                <a:latin typeface="Nanum Square"/>
+              </a:defRPr>
+            </a:pPr>
           </a:p>
           <a:p>
             <a:pPr algn="l">
               <a:spcBef>
-                <a:spcPts val="1000"/>
+                <a:spcPts val="800"/>
               </a:spcBef>
               <a:defRPr sz="1800" b="0">
                 <a:solidFill>
                   <a:srgbClr val="2D2D2D"/>
                 </a:solidFill>
-              </a:defRPr>
-            </a:pPr>
-            <a:r>
-              <a:t>•  Stays inside workspace</a:t>
+                <a:latin typeface="Nanum Square"/>
+              </a:defRPr>
+            </a:pPr>
+            <a:r>
+              <a:t>•  조건별 9회 반복 실행으로 통계적 유의미성 확보</a:t>
             </a:r>
           </a:p>
           <a:p>
             <a:pPr algn="l">
               <a:spcBef>
-                <a:spcPts val="200"/>
+                <a:spcPts val="648"/>
               </a:spcBef>
-              <a:defRPr sz="1400" b="0">
-                <a:solidFill>
-                  <a:srgbClr val="999999"/>
-                </a:solidFill>
-              </a:defRPr>
-            </a:pPr>
-            <a:r>
-              <a:t>    작업 영역 내 정상 거동</a:t>
+              <a:defRPr sz="800" b="0">
+                <a:solidFill>
+                  <a:srgbClr val="2D2D2D"/>
+                </a:solidFill>
+                <a:latin typeface="Nanum Square"/>
+              </a:defRPr>
+            </a:pPr>
+          </a:p>
+          <a:p>
+            <a:pPr algn="l">
+              <a:spcBef>
+                <a:spcPts val="800"/>
+              </a:spcBef>
+              <a:defRPr sz="1800" b="0">
+                <a:solidFill>
+                  <a:srgbClr val="2D2D2D"/>
+                </a:solidFill>
+                <a:latin typeface="Nanum Square"/>
+              </a:defRPr>
+            </a:pPr>
+            <a:r>
+              <a:t>•  z=+20 mm에서 중립자세 설정 (최대 회전)</a:t>
             </a:r>
           </a:p>
         </p:txBody>
@@ -8474,25 +8526,11 @@
                 <a:solidFill>
                   <a:srgbClr val="004AAD"/>
                 </a:solidFill>
+                <a:latin typeface="Nanum Square"/>
               </a:defRPr>
             </a:pPr>
             <a:r>
               <a:t>Logged Signals</a:t>
-            </a:r>
-          </a:p>
-          <a:p>
-            <a:pPr algn="l">
-              <a:spcBef>
-                <a:spcPts val="200"/>
-              </a:spcBef>
-              <a:defRPr sz="1600" b="0">
-                <a:solidFill>
-                  <a:srgbClr val="999999"/>
-                </a:solidFill>
-              </a:defRPr>
-            </a:pPr>
-            <a:r>
-              <a:t>기록 신호</a:t>
             </a:r>
           </a:p>
           <a:p>
@@ -8504,25 +8542,11 @@
                 <a:solidFill>
                   <a:srgbClr val="2D2D2D"/>
                 </a:solidFill>
+                <a:latin typeface="Nanum Square"/>
               </a:defRPr>
             </a:pPr>
             <a:r>
               <a:t>•  X-Plane attitude</a:t>
-            </a:r>
-          </a:p>
-          <a:p>
-            <a:pPr algn="l">
-              <a:spcBef>
-                <a:spcPts val="200"/>
-              </a:spcBef>
-              <a:defRPr sz="1600" b="0">
-                <a:solidFill>
-                  <a:srgbClr val="999999"/>
-                </a:solidFill>
-              </a:defRPr>
-            </a:pPr>
-            <a:r>
-              <a:t>    X-Plane 자세</a:t>
             </a:r>
           </a:p>
           <a:p>
@@ -8534,25 +8558,11 @@
                 <a:solidFill>
                   <a:srgbClr val="2D2D2D"/>
                 </a:solidFill>
-              </a:defRPr>
-            </a:pPr>
-            <a:r>
-              <a:t>•  PX4 attitude estimate</a:t>
-            </a:r>
-          </a:p>
-          <a:p>
-            <a:pPr algn="l">
-              <a:spcBef>
-                <a:spcPts val="200"/>
-              </a:spcBef>
-              <a:defRPr sz="1600" b="0">
-                <a:solidFill>
-                  <a:srgbClr val="999999"/>
-                </a:solidFill>
-              </a:defRPr>
-            </a:pPr>
-            <a:r>
-              <a:t>    PX4 자세 추정값</a:t>
+                <a:latin typeface="Nanum Square"/>
+              </a:defRPr>
+            </a:pPr>
+            <a:r>
+              <a:t>•  PX4 자세 추정값</a:t>
             </a:r>
           </a:p>
           <a:p>
@@ -8564,25 +8574,11 @@
                 <a:solidFill>
                   <a:srgbClr val="2D2D2D"/>
                 </a:solidFill>
-              </a:defRPr>
-            </a:pPr>
-            <a:r>
-              <a:t>•  Platform pose command</a:t>
-            </a:r>
-          </a:p>
-          <a:p>
-            <a:pPr algn="l">
-              <a:spcBef>
-                <a:spcPts val="200"/>
-              </a:spcBef>
-              <a:defRPr sz="1600" b="0">
-                <a:solidFill>
-                  <a:srgbClr val="999999"/>
-                </a:solidFill>
-              </a:defRPr>
-            </a:pPr>
-            <a:r>
-              <a:t>    플랫폼 pose 명령</a:t>
+                <a:latin typeface="Nanum Square"/>
+              </a:defRPr>
+            </a:pPr>
+            <a:r>
+              <a:t>•  플랫폼 pose command</a:t>
             </a:r>
           </a:p>
           <a:p>
@@ -8594,25 +8590,11 @@
                 <a:solidFill>
                   <a:srgbClr val="2D2D2D"/>
                 </a:solidFill>
+                <a:latin typeface="Nanum Square"/>
               </a:defRPr>
             </a:pPr>
             <a:r>
               <a:t>•  ACK timing + host timestamps</a:t>
-            </a:r>
-          </a:p>
-          <a:p>
-            <a:pPr algn="l">
-              <a:spcBef>
-                <a:spcPts val="200"/>
-              </a:spcBef>
-              <a:defRPr sz="1600" b="0">
-                <a:solidFill>
-                  <a:srgbClr val="999999"/>
-                </a:solidFill>
-              </a:defRPr>
-            </a:pPr>
-            <a:r>
-              <a:t>    ACK 타이밍 및 타임스탬프</a:t>
             </a:r>
           </a:p>
           <a:p>
@@ -8624,6 +8606,7 @@
                 <a:solidFill>
                   <a:srgbClr val="2D2D2D"/>
                 </a:solidFill>
+                <a:latin typeface="Nanum Square"/>
               </a:defRPr>
             </a:pPr>
           </a:p>
@@ -8636,25 +8619,11 @@
                 <a:solidFill>
                   <a:srgbClr val="004AAD"/>
                 </a:solidFill>
+                <a:latin typeface="Nanum Square"/>
               </a:defRPr>
             </a:pPr>
             <a:r>
               <a:t>Extracted Metrics</a:t>
-            </a:r>
-          </a:p>
-          <a:p>
-            <a:pPr algn="l">
-              <a:spcBef>
-                <a:spcPts val="200"/>
-              </a:spcBef>
-              <a:defRPr sz="1500" b="0">
-                <a:solidFill>
-                  <a:srgbClr val="999999"/>
-                </a:solidFill>
-              </a:defRPr>
-            </a:pPr>
-            <a:r>
-              <a:t>추출 메트릭</a:t>
             </a:r>
           </a:p>
           <a:p>
@@ -8666,25 +8635,11 @@
                 <a:solidFill>
                   <a:srgbClr val="2D2D2D"/>
                 </a:solidFill>
+                <a:latin typeface="Nanum Square"/>
               </a:defRPr>
             </a:pPr>
             <a:r>
               <a:t>•  Tracking error (raw)</a:t>
-            </a:r>
-          </a:p>
-          <a:p>
-            <a:pPr algn="l">
-              <a:spcBef>
-                <a:spcPts val="200"/>
-              </a:spcBef>
-              <a:defRPr sz="1600" b="0">
-                <a:solidFill>
-                  <a:srgbClr val="999999"/>
-                </a:solidFill>
-              </a:defRPr>
-            </a:pPr>
-            <a:r>
-              <a:t>    추종 오차 (원시)</a:t>
             </a:r>
           </a:p>
           <a:p>
@@ -8696,25 +8651,11 @@
                 <a:solidFill>
                   <a:srgbClr val="2D2D2D"/>
                 </a:solidFill>
+                <a:latin typeface="Nanum Square"/>
               </a:defRPr>
             </a:pPr>
             <a:r>
               <a:t>•  Bias-corrected tracking error</a:t>
-            </a:r>
-          </a:p>
-          <a:p>
-            <a:pPr algn="l">
-              <a:spcBef>
-                <a:spcPts val="200"/>
-              </a:spcBef>
-              <a:defRPr sz="1600" b="0">
-                <a:solidFill>
-                  <a:srgbClr val="999999"/>
-                </a:solidFill>
-              </a:defRPr>
-            </a:pPr>
-            <a:r>
-              <a:t>    바이어스 보정 추종 오차</a:t>
             </a:r>
           </a:p>
           <a:p>
@@ -8726,6 +8667,7 @@
                 <a:solidFill>
                   <a:srgbClr val="2D2D2D"/>
                 </a:solidFill>
+                <a:latin typeface="Nanum Square"/>
               </a:defRPr>
             </a:pPr>
             <a:r>
@@ -8741,25 +8683,11 @@
                 <a:solidFill>
                   <a:srgbClr val="2D2D2D"/>
                 </a:solidFill>
+                <a:latin typeface="Nanum Square"/>
               </a:defRPr>
             </a:pPr>
             <a:r>
               <a:t>•  Serial RTT / end-to-end delay</a:t>
-            </a:r>
-          </a:p>
-          <a:p>
-            <a:pPr algn="l">
-              <a:spcBef>
-                <a:spcPts val="200"/>
-              </a:spcBef>
-              <a:defRPr sz="1600" b="0">
-                <a:solidFill>
-                  <a:srgbClr val="999999"/>
-                </a:solidFill>
-              </a:defRPr>
-            </a:pPr>
-            <a:r>
-              <a:t>    종단간 지연</a:t>
             </a:r>
           </a:p>
         </p:txBody>
@@ -8791,6 +8719,7 @@
                 <a:solidFill>
                   <a:srgbClr val="666666"/>
                 </a:solidFill>
+                <a:latin typeface="Nanum Square"/>
               </a:defRPr>
             </a:pPr>
             <a:r>
@@ -8940,6 +8869,7 @@
                 <a:solidFill>
                   <a:srgbClr val="000000"/>
                 </a:solidFill>
+                <a:latin typeface="Nanum Square"/>
               </a:defRPr>
             </a:pPr>
             <a:r>
@@ -8965,7 +8895,7 @@
         <p:spPr>
           <a:xfrm>
             <a:off x="914400" y="3108960"/>
-            <a:ext cx="10515600" cy="4301836"/>
+            <a:ext cx="10515600" cy="4114800"/>
           </a:xfrm>
           <a:prstGeom prst="rect">
             <a:avLst/>
@@ -8999,6 +8929,7 @@
                 <a:solidFill>
                   <a:srgbClr val="2D2D2D"/>
                 </a:solidFill>
+                <a:latin typeface="Nanum Square"/>
               </a:defRPr>
             </a:pPr>
             <a:r>
@@ -9014,6 +8945,7 @@
                 <a:solidFill>
                   <a:srgbClr val="999999"/>
                 </a:solidFill>
+                <a:latin typeface="Nanum Square"/>
               </a:defRPr>
             </a:pPr>
             <a:r>
@@ -9029,6 +8961,7 @@
                 <a:solidFill>
                   <a:srgbClr val="2D2D2D"/>
                 </a:solidFill>
+                <a:latin typeface="Nanum Square"/>
               </a:defRPr>
             </a:pPr>
           </a:p>
@@ -9041,6 +8974,7 @@
                 <a:solidFill>
                   <a:srgbClr val="2D2D2D"/>
                 </a:solidFill>
+                <a:latin typeface="Nanum Square"/>
               </a:defRPr>
             </a:pPr>
             <a:r>
@@ -9060,6 +8994,7 @@
                 <a:solidFill>
                   <a:srgbClr val="999999"/>
                 </a:solidFill>
+                <a:latin typeface="Nanum Square"/>
               </a:defRPr>
             </a:pPr>
             <a:r>
@@ -9070,16 +9005,16 @@
       </p:sp>
       <p:sp>
         <p:nvSpPr>
-          <p:cNvPr id="7" name="Rectangle 6"/>
+          <p:cNvPr id="7" name="Rounded Rectangle 6"/>
           <p:cNvSpPr/>
           <p:nvPr/>
         </p:nvSpPr>
         <p:spPr>
           <a:xfrm>
-            <a:off x="2441448" y="7772400"/>
+            <a:off x="2441448" y="8046720"/>
             <a:ext cx="13405104" cy="1097280"/>
           </a:xfrm>
-          <a:prstGeom prst="rect">
+          <a:prstGeom prst="roundRect">
             <a:avLst/>
           </a:prstGeom>
           <a:solidFill>
@@ -9120,7 +9055,7 @@
         </p:nvSpPr>
         <p:spPr>
           <a:xfrm>
-            <a:off x="2807208" y="8138160"/>
+            <a:off x="2807208" y="8412480"/>
             <a:ext cx="12673584" cy="822960"/>
           </a:xfrm>
           <a:prstGeom prst="rect">
@@ -9134,11 +9069,12 @@
           </a:bodyPr>
           <a:lstStyle/>
           <a:p>
-            <a:pPr algn="l">
+            <a:pPr algn="ctr">
               <a:defRPr sz="2000" b="1">
                 <a:solidFill>
                   <a:srgbClr val="000000"/>
                 </a:solidFill>
+                <a:latin typeface="Nanum Square"/>
               </a:defRPr>
             </a:pPr>
             <a:r>
@@ -9174,6 +9110,7 @@
                 <a:solidFill>
                   <a:srgbClr val="666666"/>
                 </a:solidFill>
+                <a:latin typeface="Nanum Square"/>
               </a:defRPr>
             </a:pPr>
             <a:r>
@@ -9323,6 +9260,7 @@
                 <a:solidFill>
                   <a:srgbClr val="000000"/>
                 </a:solidFill>
+                <a:latin typeface="Nanum Square"/>
               </a:defRPr>
             </a:pPr>
             <a:r>
@@ -9348,7 +9286,7 @@
         <p:spPr>
           <a:xfrm>
             <a:off x="914400" y="3108960"/>
-            <a:ext cx="7315200" cy="2793076"/>
+            <a:ext cx="7315200" cy="3657600"/>
           </a:xfrm>
           <a:prstGeom prst="rect">
             <a:avLst/>
@@ -9372,7 +9310,7 @@
         <p:spPr>
           <a:xfrm>
             <a:off x="9144000" y="3108960"/>
-            <a:ext cx="7315200" cy="4256116"/>
+            <a:ext cx="7315200" cy="3657600"/>
           </a:xfrm>
           <a:prstGeom prst="rect">
             <a:avLst/>
@@ -9406,6 +9344,7 @@
                 <a:solidFill>
                   <a:srgbClr val="666666"/>
                 </a:solidFill>
+                <a:latin typeface="Nanum Square"/>
               </a:defRPr>
             </a:pPr>
             <a:r>
@@ -9441,6 +9380,7 @@
                 <a:solidFill>
                   <a:srgbClr val="666666"/>
                 </a:solidFill>
+                <a:latin typeface="Nanum Square"/>
               </a:defRPr>
             </a:pPr>
             <a:r>
@@ -9451,16 +9391,16 @@
       </p:sp>
       <p:sp>
         <p:nvSpPr>
-          <p:cNvPr id="9" name="Rectangle 8"/>
+          <p:cNvPr id="9" name="Rounded Rectangle 8"/>
           <p:cNvSpPr/>
           <p:nvPr/>
         </p:nvSpPr>
         <p:spPr>
           <a:xfrm>
-            <a:off x="2441448" y="7772400"/>
+            <a:off x="2441448" y="8046720"/>
             <a:ext cx="13405104" cy="1097280"/>
           </a:xfrm>
-          <a:prstGeom prst="rect">
+          <a:prstGeom prst="roundRect">
             <a:avLst/>
           </a:prstGeom>
           <a:solidFill>
@@ -9501,7 +9441,7 @@
         </p:nvSpPr>
         <p:spPr>
           <a:xfrm>
-            <a:off x="2807208" y="8138160"/>
+            <a:off x="2807208" y="8412480"/>
             <a:ext cx="12673584" cy="822960"/>
           </a:xfrm>
           <a:prstGeom prst="rect">
@@ -9515,11 +9455,12 @@
           </a:bodyPr>
           <a:lstStyle/>
           <a:p>
-            <a:pPr algn="l">
-              <a:defRPr sz="1800" b="1">
+            <a:pPr algn="ctr">
+              <a:defRPr sz="2000" b="1">
                 <a:solidFill>
                   <a:srgbClr val="000000"/>
                 </a:solidFill>
+                <a:latin typeface="Nanum Square"/>
               </a:defRPr>
             </a:pPr>
             <a:r>
@@ -9555,6 +9496,7 @@
                 <a:solidFill>
                   <a:srgbClr val="666666"/>
                 </a:solidFill>
+                <a:latin typeface="Nanum Square"/>
               </a:defRPr>
             </a:pPr>
             <a:r>
@@ -9704,6 +9646,7 @@
                 <a:solidFill>
                   <a:srgbClr val="000000"/>
                 </a:solidFill>
+                <a:latin typeface="Nanum Square"/>
               </a:defRPr>
             </a:pPr>
             <a:r>
@@ -9729,7 +9672,7 @@
         <p:spPr>
           <a:xfrm>
             <a:off x="914400" y="3108960"/>
-            <a:ext cx="7772400" cy="3179618"/>
+            <a:ext cx="7772400" cy="3474720"/>
           </a:xfrm>
           <a:prstGeom prst="rect">
             <a:avLst/>
@@ -9753,7 +9696,7 @@
         <p:spPr>
           <a:xfrm>
             <a:off x="9144000" y="3108960"/>
-            <a:ext cx="7772400" cy="3391593"/>
+            <a:ext cx="7772400" cy="3474720"/>
           </a:xfrm>
           <a:prstGeom prst="rect">
             <a:avLst/>
@@ -9787,6 +9730,7 @@
                 <a:solidFill>
                   <a:srgbClr val="004AAD"/>
                 </a:solidFill>
+                <a:latin typeface="Nanum Square"/>
               </a:defRPr>
             </a:pPr>
             <a:r>
@@ -9822,6 +9766,7 @@
                 <a:solidFill>
                   <a:srgbClr val="004AAD"/>
                 </a:solidFill>
+                <a:latin typeface="Nanum Square"/>
               </a:defRPr>
             </a:pPr>
             <a:r>
@@ -9857,6 +9802,7 @@
                 <a:solidFill>
                   <a:srgbClr val="004AAD"/>
                 </a:solidFill>
+                <a:latin typeface="Nanum Square"/>
               </a:defRPr>
             </a:pPr>
             <a:r>
@@ -9867,16 +9813,16 @@
       </p:sp>
       <p:sp>
         <p:nvSpPr>
-          <p:cNvPr id="10" name="Rectangle 9"/>
+          <p:cNvPr id="10" name="Rounded Rectangle 9"/>
           <p:cNvSpPr/>
           <p:nvPr/>
         </p:nvSpPr>
         <p:spPr>
           <a:xfrm>
-            <a:off x="2441448" y="7680960"/>
-            <a:ext cx="13405104" cy="1371600"/>
-          </a:xfrm>
-          <a:prstGeom prst="rect">
+            <a:off x="2441448" y="8046720"/>
+            <a:ext cx="13405104" cy="1097280"/>
+          </a:xfrm>
+          <a:prstGeom prst="roundRect">
             <a:avLst/>
           </a:prstGeom>
           <a:solidFill>
@@ -9917,8 +9863,8 @@
         </p:nvSpPr>
         <p:spPr>
           <a:xfrm>
-            <a:off x="2807208" y="8046720"/>
-            <a:ext cx="12673584" cy="1097280"/>
+            <a:off x="2807208" y="8412480"/>
+            <a:ext cx="12673584" cy="822960"/>
           </a:xfrm>
           <a:prstGeom prst="rect">
             <a:avLst/>
@@ -9931,11 +9877,12 @@
           </a:bodyPr>
           <a:lstStyle/>
           <a:p>
-            <a:pPr algn="l">
+            <a:pPr algn="ctr">
               <a:defRPr sz="2000" b="1">
                 <a:solidFill>
                   <a:srgbClr val="000000"/>
                 </a:solidFill>
+                <a:latin typeface="Nanum Square"/>
               </a:defRPr>
             </a:pPr>
             <a:r>
@@ -9951,6 +9898,7 @@
                 <a:solidFill>
                   <a:srgbClr val="666666"/>
                 </a:solidFill>
+                <a:latin typeface="Nanum Square"/>
               </a:defRPr>
             </a:pPr>
             <a:r>
@@ -9986,6 +9934,7 @@
                 <a:solidFill>
                   <a:srgbClr val="666666"/>
                 </a:solidFill>
+                <a:latin typeface="Nanum Square"/>
               </a:defRPr>
             </a:pPr>
             <a:r>

</xml_diff>

<commit_message>
Update presentation content: refine callout texts, enhance clarity, and adjust terminology
- Revised callout texts to better reflect experimental findings and system characteristics.
- Improved clarity in slide descriptions, emphasizing the role of the Stewart platform and the physical loop system.
- Adjusted terminology for consistency and readability throughout the presentation.
- Updated slide titles and bullet points for better alignment with the overall narrative.
</commit_message>
<xml_diff>
--- a/presentation/KSAS_Spring2026_Presentation.pptx
+++ b/presentation/KSAS_Spring2026_Presentation.pptx
@@ -3579,7 +3579,7 @@
               </a:defRPr>
             </a:pPr>
             <a:r>
-              <a:t>•  항상 동일 Honolulu (PHNL) 10nm 어프로치로 시작</a:t>
+              <a:t>•  항상 동일 Honolulu (PHNL) 10nm Approach</a:t>
             </a:r>
           </a:p>
           <a:p>
@@ -3608,36 +3608,7 @@
               </a:defRPr>
             </a:pPr>
             <a:r>
-              <a:t>•  스크립트로 적용된 유예 기간 동안 시스템 안정화 후 데이터 수집</a:t>
-            </a:r>
-          </a:p>
-          <a:p>
-            <a:pPr algn="l">
-              <a:spcBef>
-                <a:spcPts val="648"/>
-              </a:spcBef>
-              <a:defRPr sz="800" b="1">
-                <a:solidFill>
-                  <a:srgbClr val="2D2D2D"/>
-                </a:solidFill>
-                <a:latin typeface="NanumSquare Bold"/>
-              </a:defRPr>
-            </a:pPr>
-          </a:p>
-          <a:p>
-            <a:pPr algn="l">
-              <a:spcBef>
-                <a:spcPts val="800"/>
-              </a:spcBef>
-              <a:defRPr sz="2000" b="1">
-                <a:solidFill>
-                  <a:srgbClr val="2D2D2D"/>
-                </a:solidFill>
-                <a:latin typeface="NanumSquare Bold"/>
-              </a:defRPr>
-            </a:pPr>
-            <a:r>
-              <a:t>•  Stewart 플랫폼의 포화 플래그(SAT) 감시; 작업 공간 내 유지</a:t>
+              <a:t>•  Stewart 플랫폼의 포화 플래그(SAT) 감시;</a:t>
             </a:r>
           </a:p>
           <a:p>
@@ -4011,7 +3982,7 @@
               </a:defRPr>
             </a:pPr>
             <a:r>
-              <a:t>기본 조건 우선 특성화: 지연·바이어스·장착 효과를 먼저 파악해야 향후 교란·포화 실험에서 원인 분리 가능</a:t>
+              <a:t>시스템 자체 특성(지연·바이어스·장착 효과) 분리를 위해 clean baseline부터 수행</a:t>
             </a:r>
           </a:p>
         </p:txBody>
@@ -5140,8 +5111,8 @@
         </p:nvSpPr>
         <p:spPr>
           <a:xfrm>
-            <a:off x="1371600" y="6858000"/>
-            <a:ext cx="4114800" cy="548640"/>
+            <a:off x="1097280" y="6858000"/>
+            <a:ext cx="3840480" cy="548640"/>
           </a:xfrm>
           <a:prstGeom prst="rect">
             <a:avLst/>
@@ -5163,7 +5134,7 @@
               </a:defRPr>
             </a:pPr>
             <a:r>
-              <a:t>Serial RTT mean ≈ 22 ms</a:t>
+              <a:t>X-Plane age mean/median: 27.2 / 30.5 ms</a:t>
             </a:r>
           </a:p>
         </p:txBody>
@@ -5176,8 +5147,8 @@
         </p:nvSpPr>
         <p:spPr>
           <a:xfrm>
-            <a:off x="6400800" y="6858000"/>
-            <a:ext cx="4114800" cy="548640"/>
+            <a:off x="5212080" y="6858000"/>
+            <a:ext cx="3840480" cy="548640"/>
           </a:xfrm>
           <a:prstGeom prst="rect">
             <a:avLst/>
@@ -5199,7 +5170,7 @@
               </a:defRPr>
             </a:pPr>
             <a:r>
-              <a:t>PX4 rx→ACK mean ≈ 41 ms</a:t>
+              <a:t>PX4 age mean/median: 18.9 / 14.8 ms</a:t>
             </a:r>
           </a:p>
         </p:txBody>
@@ -5212,8 +5183,8 @@
         </p:nvSpPr>
         <p:spPr>
           <a:xfrm>
-            <a:off x="11887200" y="6858000"/>
-            <a:ext cx="4114800" cy="548640"/>
+            <a:off x="9326880" y="6858000"/>
+            <a:ext cx="3840480" cy="548640"/>
           </a:xfrm>
           <a:prstGeom prst="rect">
             <a:avLst/>
@@ -5235,14 +5206,50 @@
               </a:defRPr>
             </a:pPr>
             <a:r>
-              <a:t>X-Plane rx→ACK mean ≈ 51 ms</a:t>
-            </a:r>
-          </a:p>
-        </p:txBody>
-      </p:sp>
-      <p:sp>
-        <p:nvSpPr>
-          <p:cNvPr id="10" name="Rounded Rectangle 9"/>
+              <a:t>Serial RTT mean/median: 21.7 / 17.1 ms</a:t>
+            </a:r>
+          </a:p>
+        </p:txBody>
+      </p:sp>
+      <p:sp>
+        <p:nvSpPr>
+          <p:cNvPr id="10" name="TextBox 9"/>
+          <p:cNvSpPr txBox="1"/>
+          <p:nvPr/>
+        </p:nvSpPr>
+        <p:spPr>
+          <a:xfrm>
+            <a:off x="13441680" y="6858000"/>
+            <a:ext cx="3840480" cy="548640"/>
+          </a:xfrm>
+          <a:prstGeom prst="rect">
+            <a:avLst/>
+          </a:prstGeom>
+          <a:noFill/>
+        </p:spPr>
+        <p:txBody>
+          <a:bodyPr wrap="none">
+            <a:spAutoFit/>
+          </a:bodyPr>
+          <a:lstStyle/>
+          <a:p>
+            <a:pPr algn="ctr">
+              <a:defRPr b="1" sz="2000">
+                <a:solidFill>
+                  <a:srgbClr val="004AAD"/>
+                </a:solidFill>
+                <a:latin typeface="NanumSquare Bold"/>
+              </a:defRPr>
+            </a:pPr>
+            <a:r>
+              <a:t>End-to-end mean/median: 48.9 / 48.2 ms</a:t>
+            </a:r>
+          </a:p>
+        </p:txBody>
+      </p:sp>
+      <p:sp>
+        <p:nvSpPr>
+          <p:cNvPr id="11" name="Rounded Rectangle 10"/>
           <p:cNvSpPr/>
           <p:nvPr/>
         </p:nvSpPr>
@@ -5286,7 +5293,7 @@
       </p:sp>
       <p:sp>
         <p:nvSpPr>
-          <p:cNvPr id="11" name="TextBox 10"/>
+          <p:cNvPr id="12" name="TextBox 11"/>
           <p:cNvSpPr txBox="1"/>
           <p:nvPr/>
         </p:nvSpPr>
@@ -5322,7 +5329,7 @@
       </p:sp>
       <p:sp>
         <p:nvSpPr>
-          <p:cNvPr id="12" name="TextBox 11"/>
+          <p:cNvPr id="13" name="TextBox 12"/>
           <p:cNvSpPr txBox="1"/>
           <p:nvPr/>
         </p:nvSpPr>
@@ -5573,7 +5580,11 @@
               </a:defRPr>
             </a:pPr>
             <a:r>
-              <a:t>2.  충실도: 폐루프 자세 추종 달성 및 정량적 평가</a:t>
+              <a:t>2.  충실도: RMSE ~0.46° 추종 오차,</a:t>
+            </a:r>
+            <a:br/>
+            <a:r>
+              <a:t>E2E 지연 ~51 ms로 정량 검증</a:t>
             </a:r>
           </a:p>
           <a:p>
@@ -6292,7 +6303,7 @@
               </a:defRPr>
             </a:pPr>
             <a:r>
-              <a:t>→ ~20° rotation range</a:t>
+              <a:t>→ available range at this z</a:t>
             </a:r>
           </a:p>
           <a:p>
@@ -6308,11 +6319,11 @@
               </a:defRPr>
             </a:pPr>
             <a:r>
-              <a:t>Sufficient for ±5° trim test</a:t>
+              <a:t>worst-direction limit ~20°;</a:t>
             </a:r>
             <a:br/>
             <a:r>
-              <a:t>with large margin.</a:t>
+              <a:t>sufficient margin for baseline trim test.</a:t>
             </a:r>
           </a:p>
           <a:p>
@@ -6357,7 +6368,7 @@
               </a:defRPr>
             </a:pPr>
             <a:r>
-              <a:t>→ ~10° rotation range</a:t>
+              <a:t>→ smaller available range</a:t>
             </a:r>
           </a:p>
           <a:p>
@@ -6373,7 +6384,11 @@
               </a:defRPr>
             </a:pPr>
             <a:r>
-              <a:t>Insufficient for ±5° test.</a:t>
+              <a:t>worst-direction limit ~10°;</a:t>
+            </a:r>
+            <a:br/>
+            <a:r>
+              <a:t>less margin than z=+20 mm.</a:t>
             </a:r>
           </a:p>
         </p:txBody>
@@ -6801,11 +6816,15 @@
               </a:defRPr>
             </a:pPr>
             <a:r>
-              <a:t>Baseline ±5° out of ~20° available.</a:t>
+              <a:t>Baseline mostly within available</a:t>
             </a:r>
             <a:br/>
             <a:r>
-              <a:t>Stress tests planned. → Sl 8+10+14</a:t>
+              <a:t>range at z=+20 mm; sat 0-1%.</a:t>
+            </a:r>
+            <a:br/>
+            <a:r>
+              <a:t>Stress tests planned. → Sl 10+13+14</a:t>
             </a:r>
           </a:p>
         </p:txBody>
@@ -6924,11 +6943,15 @@
               </a:defRPr>
             </a:pPr>
             <a:r>
-              <a:t>~50 Hz tick, E2E latency ~51 ms.</a:t>
+              <a:t>Placeholder: BW ~X.X Hz, phase</a:t>
             </a:r>
             <a:br/>
             <a:r>
-              <a:t>Low-freq maneuvers suited. → Sl 7+13</a:t>
+              <a:t>~Y° @ 1 Hz from sine sweep.</a:t>
+            </a:r>
+            <a:br/>
+            <a:r>
+              <a:t>Current data: E2E ~51 ms. → Sl 13</a:t>
             </a:r>
           </a:p>
         </p:txBody>
@@ -8242,7 +8265,7 @@
               </a:defRPr>
             </a:pPr>
             <a:r>
-              <a:t>합성 IMU 주입을 넘어, 실제 모션이 PX4 추정기에 어떻게 반영되는지 검증하는 중간 검증 레이어</a:t>
+              <a:t>물리 폐루프 시험 환경이 안정적으로 동작하고 추종 성능을 정량화할 수 있음을 실험 데이터로 입증</a:t>
             </a:r>
           </a:p>
         </p:txBody>
@@ -8928,7 +8951,7 @@
               </a:defRPr>
             </a:pPr>
             <a:r>
-              <a:t>구조적으로 특정 기체에 종속되지 않음 — 다른 기체로의 확장 실증은 향후 과제</a:t>
+              <a:t>스튜어트 플랫폼은 시뮬레이터와 비행 제어기 사이의 물리적 연결 고리</a:t>
             </a:r>
           </a:p>
           <a:p>
@@ -8944,7 +8967,7 @@
               </a:defRPr>
             </a:pPr>
             <a:r>
-              <a:t>보완적 검증 수단 - 전 영역 공력 재현이 아닌, 추정기 반응 중심의 물리적 검증 설계</a:t>
+              <a:t>소프트웨어 자세 명령을 실제 6-DOF 모션으로 변환해 PX4 IMU가 실제 운동을 경험</a:t>
             </a:r>
           </a:p>
         </p:txBody>
@@ -10100,11 +10123,11 @@
               </a:defRPr>
             </a:pPr>
             <a:r>
-              <a:t>PX4 attitude returns to host,</a:t>
+              <a:t>PX4 attitude returns to host;</a:t>
             </a:r>
             <a:br/>
             <a:r>
-              <a:t>which closes the loop in X-Plane.</a:t>
+              <a:t>host PID injects control to X-Plane.</a:t>
             </a:r>
           </a:p>
         </p:txBody>
@@ -10653,8 +10676,9 @@
                 <a:latin typeface="NanumSquare Bold"/>
               </a:defRPr>
             </a:pPr>
-            <a:r>
-              <a:t>역할</a:t>
+            <a:br/>
+            <a:r>
+              <a:t>ROLE</a:t>
             </a:r>
           </a:p>
           <a:p>
@@ -10715,7 +10739,7 @@
               </a:defRPr>
             </a:pPr>
             <a:r>
-              <a:t>이 시스템에서 달라지는 점</a:t>
+              <a:t>KEY POINT</a:t>
             </a:r>
           </a:p>
           <a:p>
@@ -10747,7 +10771,11 @@
               </a:defRPr>
             </a:pPr>
             <a:r>
-              <a:t>•  이 구조에서는 물리적으로 센싱된 PX4 자세가 제어 입력으로 돌아옴</a:t>
+              <a:t>•  이 구조에서는 PX4 자세가 호스트 PID를 거쳐</a:t>
+            </a:r>
+            <a:br/>
+            <a:r>
+              <a:t>  제어 입력으로 되돌아옴</a:t>
             </a:r>
           </a:p>
         </p:txBody>
@@ -11260,8 +11288,9 @@
                 <a:latin typeface="NanumSquare Bold"/>
               </a:defRPr>
             </a:pPr>
-            <a:r>
-              <a:t>수신</a:t>
+            <a:br/>
+            <a:r>
+              <a:t>RECEIVE</a:t>
             </a:r>
           </a:p>
           <a:p>
@@ -11322,7 +11351,7 @@
               </a:defRPr>
             </a:pPr>
             <a:r>
-              <a:t>처리</a:t>
+              <a:t>PROCESS</a:t>
             </a:r>
           </a:p>
           <a:p>
@@ -11383,7 +11412,7 @@
               </a:defRPr>
             </a:pPr>
             <a:r>
-              <a:t>송신</a:t>
+              <a:t>RETURN</a:t>
             </a:r>
           </a:p>
           <a:p>
@@ -11415,7 +11444,7 @@
               </a:defRPr>
             </a:pPr>
             <a:r>
-              <a:t>•  PX4 자세 → X-Plane 제어 입력으로 주입 (UDP)</a:t>
+              <a:t>•  PX4 자세 → Host PID → X-Plane 제어 입력 주입 (UDP)</a:t>
             </a:r>
           </a:p>
         </p:txBody>
@@ -11928,8 +11957,9 @@
                 <a:latin typeface="NanumSquare Bold"/>
               </a:defRPr>
             </a:pPr>
-            <a:r>
-              <a:t>역할</a:t>
+            <a:br/>
+            <a:r>
+              <a:t>ROLE</a:t>
             </a:r>
           </a:p>
           <a:p>
@@ -11961,7 +11991,7 @@
               </a:defRPr>
             </a:pPr>
             <a:r>
-              <a:t>•  작업 공간과 포화 한계를 적용 (saturator)</a:t>
+              <a:t>•  가동범위 포화 한계를 적용 (saturator)</a:t>
             </a:r>
           </a:p>
           <a:p>
@@ -11990,7 +12020,7 @@
               </a:defRPr>
             </a:pPr>
             <a:r>
-              <a:t>호스트에 반환하는 정보</a:t>
+              <a:t>RETURN</a:t>
             </a:r>
           </a:p>
           <a:p>
@@ -12051,7 +12081,7 @@
               </a:defRPr>
             </a:pPr>
             <a:r>
-              <a:t>핵심</a:t>
+              <a:t>KEY POINT</a:t>
             </a:r>
           </a:p>
           <a:p>
@@ -12067,7 +12097,23 @@
               </a:defRPr>
             </a:pPr>
             <a:r>
-              <a:t>•  이 블록 이후부터 PX4가 경험하는 것은 합성 신호가 아닌 실제 관성 운동</a:t>
+              <a:t>•  Serial RTT ~22 ms + Servo PWM 50 Hz(20 ms) → 루프 ~50 Hz</a:t>
+            </a:r>
+          </a:p>
+          <a:p>
+            <a:pPr algn="l">
+              <a:spcBef>
+                <a:spcPts val="800"/>
+              </a:spcBef>
+              <a:defRPr sz="2000" b="1">
+                <a:solidFill>
+                  <a:srgbClr val="2D2D2D"/>
+                </a:solidFill>
+                <a:latin typeface="NanumSquare Bold"/>
+              </a:defRPr>
+            </a:pPr>
+            <a:r>
+              <a:t>•  이 블록 이후부터 PX4가 경험하는 것은 실제 관성 운동</a:t>
             </a:r>
           </a:p>
         </p:txBody>
@@ -12580,8 +12626,9 @@
                 <a:latin typeface="NanumSquare Bold"/>
               </a:defRPr>
             </a:pPr>
-            <a:r>
-              <a:t>센싱</a:t>
+            <a:br/>
+            <a:r>
+              <a:t>SENSING</a:t>
             </a:r>
           </a:p>
           <a:p>
@@ -12642,7 +12689,7 @@
               </a:defRPr>
             </a:pPr>
             <a:r>
-              <a:t>귀환</a:t>
+              <a:t>RETURN</a:t>
             </a:r>
           </a:p>
           <a:p>
@@ -12674,7 +12721,7 @@
               </a:defRPr>
             </a:pPr>
             <a:r>
-              <a:t>•  호스트가 이 값을 X-Plane에 주입하여 물리 루프 완성</a:t>
+              <a:t>•  호스트 PID가 조종면 명령 계산 후 X-Plane에 주입</a:t>
             </a:r>
           </a:p>
           <a:p>
@@ -12703,7 +12750,7 @@
               </a:defRPr>
             </a:pPr>
             <a:r>
-              <a:t>검증 대상</a:t>
+              <a:t>KEY POINT</a:t>
             </a:r>
           </a:p>
           <a:p>
@@ -12719,7 +12766,7 @@
               </a:defRPr>
             </a:pPr>
             <a:r>
-              <a:t>•  루프에서 유일한 물리적 관측 주체 — 추정기 반응 자체가 검증 목표</a:t>
+              <a:t>•  유일한 물리적 관측 주체 — 추정기 반응 자체가 검증 목표</a:t>
             </a:r>
           </a:p>
         </p:txBody>

</xml_diff>